<commit_message>
Pitch: MongoDB slide shows the one-platform retrieval pipeline
</commit_message>
<xml_diff>
--- a/pitch/MrMunch.pptx
+++ b/pitch/MrMunch.pptx
@@ -113,37 +113,37 @@
   <p:extLst>
     <p:ext uri="{521415D9-36F7-43E2-AB2F-B90AF26B5E84}">
       <p14:sectionLst xmlns:p14="http://schemas.microsoft.com/office/powerpoint/2010/main">
-        <p14:section name="Intro" id="{dbf1dc11-e407-91aa-8602-7a6766660f7a}">
+        <p14:section name="Intro" id="{e0952755-9d45-b05b-9020-d65682e3f872}">
           <p14:sldIdLst>
             <p14:sldId id="256"/>
           </p14:sldIdLst>
         </p14:section>
-        <p14:section name="Problem" id="{73037a12-8c03-e78d-aa55-b3ce65bf76b6}">
+        <p14:section name="Problem" id="{90f5c36d-dadc-589e-9eb3-93b69b2ad43b}">
           <p14:sldIdLst>
             <p14:sldId id="257"/>
           </p14:sldIdLst>
         </p14:section>
-        <p14:section name="Solution" id="{d6a2f733-4db0-e382-be2c-81b846f887be}">
+        <p14:section name="Solution" id="{df824840-d7e3-0857-6f34-45cc9dad52b0}">
           <p14:sldIdLst>
             <p14:sldId id="258"/>
           </p14:sldIdLst>
         </p14:section>
-        <p14:section name="Demo" id="{2e0454a1-8e33-0c58-9d29-a6ebae54bd66}">
+        <p14:section name="Demo" id="{bce3b1c1-877f-1e3e-f2a7-21c4bb62029e}">
           <p14:sldIdLst>
             <p14:sldId id="259"/>
           </p14:sldIdLst>
         </p14:section>
-        <p14:section name="MongoDB Atlas" id="{76c86268-f1f7-2237-d920-ac94a537f522}">
+        <p14:section name="MongoDB Atlas" id="{80e9cbfe-fd08-8b17-c2b2-c01c5f2e42f0}">
           <p14:sldIdLst>
             <p14:sldId id="260"/>
           </p14:sldIdLst>
         </p14:section>
-        <p14:section name="Trust" id="{a8556bcf-1787-aaba-a8c7-c02138368bf5}">
+        <p14:section name="Trust" id="{9abe7f85-9513-3a20-bfb0-d65a15c4b5b9}">
           <p14:sldIdLst>
             <p14:sldId id="261"/>
           </p14:sldIdLst>
         </p14:section>
-        <p14:section name="Close" id="{e1a4b158-68f7-c3fb-d8d3-90e9d0413cdb}">
+        <p14:section name="Close" id="{71412cd2-3e94-a151-b43b-b62b4bea013f}">
           <p14:sldIdLst>
             <p14:sldId id="262"/>
           </p14:sldIdLst>
@@ -924,11 +924,11 @@
             <a:r>
               <a:rPr lang="en-US" dirty="0"/>
               <a:t>[Marco, ~30 s]
-MongoDB Atlas is the shared brain.
-Every dish we read is stored once with a search text that Atlas embeds automatically with Voyage AI, with no embedding code on our side.
-Recommendations start with a hybrid search: $rankFusion combines Atlas full-text search and vector search, filtered so dishes with your allergens never come back, and Voyage reranks the results.
-And it compounds: every menu one person reads or photographs makes the next search smarter. We already have more than 750 dishes.
-Next: Stream Processing turns menu contributions into an event stream.</a:t>
+MongoDB Atlas is the shared brain, and it's one platform: no separate vector database, embedding pipeline or search engine.
+Every dish we read is stored once and Atlas embeds it automatically with Voyage AI.
+Recommendations run a hybrid search: $rankFusion combines full-text search, for exact words like prawn or gluten, with vector search, for meaning, and filters out dishes with your allergens. Voyage reranks the results.
+Then the LLM writes the answer only from the dishes Atlas returned, so it can't invent a menu.
+And it compounds: every menu one person reads makes the next search smarter. We already have more than 750 dishes.</a:t>
             </a:r>
             <a:endParaRPr lang="en-US" dirty="0"/>
           </a:p>
@@ -4411,49 +4411,101 @@
       </p:sp>
       <p:sp>
         <p:nvSpPr>
-          <p:cNvPr id="3" name="Feature card 1"/>
+          <p:cNvPr id="3" name="Subtitle"/>
+          <p:cNvSpPr txBox="1"/>
+          <p:nvPr/>
+        </p:nvSpPr>
+        <p:spPr>
+          <a:xfrm>
+            <a:off x="548640" y="1024128"/>
+            <a:ext cx="8046720" cy="274320"/>
+          </a:xfrm>
+          <a:prstGeom prst="rect">
+            <a:avLst/>
+          </a:prstGeom>
+          <a:noFill/>
+          <a:ln/>
+        </p:spPr>
+        <p:txBody>
+          <a:bodyPr wrap="square" lIns="0" tIns="0" rIns="0" bIns="0" rtlCol="0" anchor="ctr"/>
+          <a:lstStyle/>
+          <a:p>
+            <a:pPr indent="0" marL="0">
+              <a:buNone/>
+            </a:pPr>
+            <a:r>
+              <a:rPr lang="en-US" sz="1400" dirty="0">
+                <a:solidFill>
+                  <a:schemeClr val="accent3"/>
+                </a:solidFill>
+              </a:rPr>
+              <a:t>One platform for data, search, embeddings and reranking. No stitching.</a:t>
+            </a:r>
+            <a:endParaRPr lang="en-US" sz="1400" dirty="0"/>
+          </a:p>
+        </p:txBody>
+      </p:sp>
+      <p:sp>
+        <p:nvSpPr>
+          <p:cNvPr id="4" name="Pipeline step 1"/>
           <p:cNvSpPr/>
           <p:nvPr/>
         </p:nvSpPr>
         <p:spPr>
           <a:xfrm>
-            <a:off x="548640" y="1325880"/>
-            <a:ext cx="2743200" cy="914400"/>
+            <a:off x="548640" y="1463040"/>
+            <a:ext cx="1325880" cy="566928"/>
           </a:xfrm>
           <a:prstGeom prst="roundRect">
             <a:avLst>
-              <a:gd name="adj" fmla="val 10000"/>
+              <a:gd name="adj" fmla="val 16129"/>
             </a:avLst>
           </a:prstGeom>
           <a:solidFill>
-            <a:schemeClr val="bg2"/>
+            <a:schemeClr val="tx2"/>
           </a:solidFill>
           <a:ln/>
         </p:spPr>
       </p:sp>
       <p:sp>
         <p:nvSpPr>
-          <p:cNvPr id="4" name="Feature circle 1"/>
-          <p:cNvSpPr/>
-          <p:nvPr/>
-        </p:nvSpPr>
-        <p:spPr>
-          <a:xfrm>
-            <a:off x="713232" y="1572768"/>
-            <a:ext cx="420624" cy="420624"/>
-          </a:xfrm>
-          <a:prstGeom prst="ellipse">
-            <a:avLst/>
-          </a:prstGeom>
-          <a:solidFill>
-            <a:schemeClr val="accent1"/>
-          </a:solidFill>
-          <a:ln/>
-        </p:spPr>
+          <p:cNvPr id="5" name="Pipeline label 1"/>
+          <p:cNvSpPr txBox="1"/>
+          <p:nvPr/>
+        </p:nvSpPr>
+        <p:spPr>
+          <a:xfrm>
+            <a:off x="548640" y="1463040"/>
+            <a:ext cx="1325880" cy="566928"/>
+          </a:xfrm>
+          <a:prstGeom prst="rect">
+            <a:avLst/>
+          </a:prstGeom>
+          <a:noFill/>
+          <a:ln/>
+        </p:spPr>
+        <p:txBody>
+          <a:bodyPr wrap="square" lIns="0" tIns="0" rIns="0" bIns="0" rtlCol="0" anchor="ctr"/>
+          <a:lstStyle/>
+          <a:p>
+            <a:pPr algn="ctr" indent="0" marL="0">
+              <a:buNone/>
+            </a:pPr>
+            <a:r>
+              <a:rPr lang="en-US" sz="1100" b="1" dirty="0">
+                <a:solidFill>
+                  <a:schemeClr val="bg1"/>
+                </a:solidFill>
+              </a:rPr>
+              <a:t>Menu read</a:t>
+            </a:r>
+            <a:endParaRPr lang="en-US" sz="1100" dirty="0"/>
+          </a:p>
+        </p:txBody>
       </p:sp>
       <p:pic>
         <p:nvPicPr>
-          <p:cNvPr id="5" name="Feature icon 1" descr="Atlas Search icon">    </p:cNvPr>
+          <p:cNvPr id="6" name="Pipeline arrow 1" descr="then">    </p:cNvPr>
           <p:cNvPicPr>
             <a:picLocks noChangeAspect="1"/>
           </p:cNvPicPr>
@@ -4467,8 +4519,8 @@
         </p:blipFill>
         <p:spPr>
           <a:xfrm>
-            <a:off x="813816" y="1673352"/>
-            <a:ext cx="219456" cy="219456"/>
+            <a:off x="1938528" y="1645920"/>
+            <a:ext cx="201168" cy="201168"/>
           </a:xfrm>
           <a:prstGeom prst="rect">
             <a:avLst/>
@@ -4477,121 +4529,79 @@
       </p:pic>
       <p:sp>
         <p:nvSpPr>
-          <p:cNvPr id="6" name="Feature name 1"/>
-          <p:cNvSpPr txBox="1"/>
-          <p:nvPr/>
-        </p:nvSpPr>
-        <p:spPr>
-          <a:xfrm>
-            <a:off x="1261872" y="1472184"/>
-            <a:ext cx="1965960" cy="292608"/>
-          </a:xfrm>
-          <a:prstGeom prst="rect">
-            <a:avLst/>
-          </a:prstGeom>
-          <a:noFill/>
-          <a:ln/>
-        </p:spPr>
-        <p:txBody>
-          <a:bodyPr wrap="square" lIns="0" tIns="0" rIns="0" bIns="0" rtlCol="0" anchor="ctr"/>
-          <a:lstStyle/>
-          <a:p>
-            <a:pPr indent="0" marL="0">
-              <a:buNone/>
-            </a:pPr>
-            <a:r>
-              <a:rPr lang="en-US" sz="1300" b="1" dirty="0">
-                <a:solidFill>
-                  <a:schemeClr val="tx1"/>
-                </a:solidFill>
-              </a:rPr>
-              <a:t>Atlas Search</a:t>
-            </a:r>
-            <a:endParaRPr lang="en-US" sz="1300" dirty="0"/>
-          </a:p>
-        </p:txBody>
-      </p:sp>
-      <p:sp>
-        <p:nvSpPr>
-          <p:cNvPr id="7" name="Feature text 1"/>
-          <p:cNvSpPr txBox="1"/>
-          <p:nvPr/>
-        </p:nvSpPr>
-        <p:spPr>
-          <a:xfrm>
-            <a:off x="1261872" y="1764792"/>
-            <a:ext cx="1965960" cy="365760"/>
-          </a:xfrm>
-          <a:prstGeom prst="rect">
-            <a:avLst/>
-          </a:prstGeom>
-          <a:noFill/>
-          <a:ln/>
-        </p:spPr>
-        <p:txBody>
-          <a:bodyPr wrap="square" lIns="0" tIns="0" rIns="0" bIns="0" rtlCol="0" anchor="t"/>
-          <a:lstStyle/>
-          <a:p>
-            <a:pPr indent="0" marL="0">
-              <a:buNone/>
-            </a:pPr>
-            <a:r>
-              <a:rPr lang="en-US" sz="1100" dirty="0">
-                <a:solidFill>
-                  <a:schemeClr val="accent3"/>
-                </a:solidFill>
-              </a:rPr>
-              <a:t>Full-text over dishes and restaurants</a:t>
-            </a:r>
-            <a:endParaRPr lang="en-US" sz="1100" dirty="0"/>
-          </a:p>
-        </p:txBody>
-      </p:sp>
-      <p:sp>
-        <p:nvSpPr>
-          <p:cNvPr id="8" name="Feature card 2"/>
+          <p:cNvPr id="7" name="Pipeline step 2"/>
           <p:cNvSpPr/>
           <p:nvPr/>
         </p:nvSpPr>
         <p:spPr>
           <a:xfrm>
-            <a:off x="3429000" y="1325880"/>
-            <a:ext cx="2743200" cy="914400"/>
+            <a:off x="2194560" y="1463040"/>
+            <a:ext cx="1325880" cy="566928"/>
           </a:xfrm>
           <a:prstGeom prst="roundRect">
             <a:avLst>
-              <a:gd name="adj" fmla="val 10000"/>
+              <a:gd name="adj" fmla="val 16129"/>
             </a:avLst>
           </a:prstGeom>
           <a:solidFill>
-            <a:schemeClr val="bg2"/>
+            <a:schemeClr val="tx2"/>
           </a:solidFill>
           <a:ln/>
         </p:spPr>
       </p:sp>
       <p:sp>
         <p:nvSpPr>
-          <p:cNvPr id="9" name="Feature circle 2"/>
-          <p:cNvSpPr/>
-          <p:nvPr/>
-        </p:nvSpPr>
-        <p:spPr>
-          <a:xfrm>
-            <a:off x="3593592" y="1572768"/>
-            <a:ext cx="420624" cy="420624"/>
-          </a:xfrm>
-          <a:prstGeom prst="ellipse">
-            <a:avLst/>
-          </a:prstGeom>
-          <a:solidFill>
-            <a:schemeClr val="accent1"/>
-          </a:solidFill>
-          <a:ln/>
-        </p:spPr>
+          <p:cNvPr id="8" name="Pipeline label 2"/>
+          <p:cNvSpPr txBox="1"/>
+          <p:nvPr/>
+        </p:nvSpPr>
+        <p:spPr>
+          <a:xfrm>
+            <a:off x="2194560" y="1463040"/>
+            <a:ext cx="1325880" cy="566928"/>
+          </a:xfrm>
+          <a:prstGeom prst="rect">
+            <a:avLst/>
+          </a:prstGeom>
+          <a:noFill/>
+          <a:ln/>
+        </p:spPr>
+        <p:txBody>
+          <a:bodyPr wrap="square" lIns="0" tIns="0" rIns="0" bIns="0" rtlCol="0" anchor="ctr"/>
+          <a:lstStyle/>
+          <a:p>
+            <a:pPr algn="ctr" indent="0" marL="0">
+              <a:buNone/>
+            </a:pPr>
+            <a:r>
+              <a:rPr lang="en-US" sz="1100" b="1" dirty="0">
+                <a:solidFill>
+                  <a:schemeClr val="bg1"/>
+                </a:solidFill>
+              </a:rPr>
+              <a:t>Auto-embed</a:t>
+            </a:r>
+            <a:endParaRPr lang="en-US" sz="1100" dirty="0"/>
+          </a:p>
+          <a:p>
+            <a:pPr algn="ctr" indent="0" marL="0">
+              <a:buNone/>
+            </a:pPr>
+            <a:r>
+              <a:rPr lang="en-US" sz="1100" b="1" dirty="0">
+                <a:solidFill>
+                  <a:schemeClr val="bg1"/>
+                </a:solidFill>
+              </a:rPr>
+              <a:t>voyage-4</a:t>
+            </a:r>
+            <a:endParaRPr lang="en-US" sz="1100" dirty="0"/>
+          </a:p>
+        </p:txBody>
       </p:sp>
       <p:pic>
         <p:nvPicPr>
-          <p:cNvPr id="10" name="Feature icon 2" descr="Vector Search icon">    </p:cNvPr>
+          <p:cNvPr id="9" name="Pipeline arrow 2" descr="then">    </p:cNvPr>
           <p:cNvPicPr>
             <a:picLocks noChangeAspect="1"/>
           </p:cNvPicPr>
@@ -4605,8 +4615,8 @@
         </p:blipFill>
         <p:spPr>
           <a:xfrm>
-            <a:off x="3694176" y="1673352"/>
-            <a:ext cx="219456" cy="219456"/>
+            <a:off x="3584448" y="1645920"/>
+            <a:ext cx="201168" cy="201168"/>
           </a:xfrm>
           <a:prstGeom prst="rect">
             <a:avLst/>
@@ -4615,121 +4625,79 @@
       </p:pic>
       <p:sp>
         <p:nvSpPr>
-          <p:cNvPr id="11" name="Feature name 2"/>
-          <p:cNvSpPr txBox="1"/>
-          <p:nvPr/>
-        </p:nvSpPr>
-        <p:spPr>
-          <a:xfrm>
-            <a:off x="4142232" y="1472184"/>
-            <a:ext cx="1965960" cy="292608"/>
-          </a:xfrm>
-          <a:prstGeom prst="rect">
-            <a:avLst/>
-          </a:prstGeom>
-          <a:noFill/>
-          <a:ln/>
-        </p:spPr>
-        <p:txBody>
-          <a:bodyPr wrap="square" lIns="0" tIns="0" rIns="0" bIns="0" rtlCol="0" anchor="ctr"/>
-          <a:lstStyle/>
-          <a:p>
-            <a:pPr indent="0" marL="0">
-              <a:buNone/>
-            </a:pPr>
-            <a:r>
-              <a:rPr lang="en-US" sz="1300" b="1" dirty="0">
-                <a:solidFill>
-                  <a:schemeClr val="tx1"/>
-                </a:solidFill>
-              </a:rPr>
-              <a:t>Vector Search</a:t>
-            </a:r>
-            <a:endParaRPr lang="en-US" sz="1300" dirty="0"/>
-          </a:p>
-        </p:txBody>
-      </p:sp>
-      <p:sp>
-        <p:nvSpPr>
-          <p:cNvPr id="12" name="Feature text 2"/>
-          <p:cNvSpPr txBox="1"/>
-          <p:nvPr/>
-        </p:nvSpPr>
-        <p:spPr>
-          <a:xfrm>
-            <a:off x="4142232" y="1764792"/>
-            <a:ext cx="1965960" cy="365760"/>
-          </a:xfrm>
-          <a:prstGeom prst="rect">
-            <a:avLst/>
-          </a:prstGeom>
-          <a:noFill/>
-          <a:ln/>
-        </p:spPr>
-        <p:txBody>
-          <a:bodyPr wrap="square" lIns="0" tIns="0" rIns="0" bIns="0" rtlCol="0" anchor="t"/>
-          <a:lstStyle/>
-          <a:p>
-            <a:pPr indent="0" marL="0">
-              <a:buNone/>
-            </a:pPr>
-            <a:r>
-              <a:rPr lang="en-US" sz="1100" dirty="0">
-                <a:solidFill>
-                  <a:schemeClr val="accent3"/>
-                </a:solidFill>
-              </a:rPr>
-              <a:t>Semantic search on every dish</a:t>
-            </a:r>
-            <a:endParaRPr lang="en-US" sz="1100" dirty="0"/>
-          </a:p>
-        </p:txBody>
-      </p:sp>
-      <p:sp>
-        <p:nvSpPr>
-          <p:cNvPr id="13" name="Feature card 3"/>
+          <p:cNvPr id="10" name="Pipeline step 3"/>
           <p:cNvSpPr/>
           <p:nvPr/>
         </p:nvSpPr>
         <p:spPr>
           <a:xfrm>
-            <a:off x="548640" y="2377440"/>
-            <a:ext cx="2743200" cy="914400"/>
+            <a:off x="3840480" y="1463040"/>
+            <a:ext cx="1325880" cy="566928"/>
           </a:xfrm>
           <a:prstGeom prst="roundRect">
             <a:avLst>
-              <a:gd name="adj" fmla="val 10000"/>
+              <a:gd name="adj" fmla="val 16129"/>
             </a:avLst>
           </a:prstGeom>
           <a:solidFill>
-            <a:schemeClr val="bg2"/>
+            <a:schemeClr val="tx2"/>
           </a:solidFill>
           <a:ln/>
         </p:spPr>
       </p:sp>
       <p:sp>
         <p:nvSpPr>
-          <p:cNvPr id="14" name="Feature circle 3"/>
-          <p:cNvSpPr/>
-          <p:nvPr/>
-        </p:nvSpPr>
-        <p:spPr>
-          <a:xfrm>
-            <a:off x="713232" y="2624328"/>
-            <a:ext cx="420624" cy="420624"/>
-          </a:xfrm>
-          <a:prstGeom prst="ellipse">
-            <a:avLst/>
-          </a:prstGeom>
-          <a:solidFill>
-            <a:schemeClr val="accent1"/>
-          </a:solidFill>
-          <a:ln/>
-        </p:spPr>
+          <p:cNvPr id="11" name="Pipeline label 3"/>
+          <p:cNvSpPr txBox="1"/>
+          <p:nvPr/>
+        </p:nvSpPr>
+        <p:spPr>
+          <a:xfrm>
+            <a:off x="3840480" y="1463040"/>
+            <a:ext cx="1325880" cy="566928"/>
+          </a:xfrm>
+          <a:prstGeom prst="rect">
+            <a:avLst/>
+          </a:prstGeom>
+          <a:noFill/>
+          <a:ln/>
+        </p:spPr>
+        <p:txBody>
+          <a:bodyPr wrap="square" lIns="0" tIns="0" rIns="0" bIns="0" rtlCol="0" anchor="ctr"/>
+          <a:lstStyle/>
+          <a:p>
+            <a:pPr algn="ctr" indent="0" marL="0">
+              <a:buNone/>
+            </a:pPr>
+            <a:r>
+              <a:rPr lang="en-US" sz="1100" b="1" dirty="0">
+                <a:solidFill>
+                  <a:schemeClr val="bg1"/>
+                </a:solidFill>
+              </a:rPr>
+              <a:t>Text + vector</a:t>
+            </a:r>
+            <a:endParaRPr lang="en-US" sz="1100" dirty="0"/>
+          </a:p>
+          <a:p>
+            <a:pPr algn="ctr" indent="0" marL="0">
+              <a:buNone/>
+            </a:pPr>
+            <a:r>
+              <a:rPr lang="en-US" sz="1100" b="1" dirty="0">
+                <a:solidFill>
+                  <a:schemeClr val="bg1"/>
+                </a:solidFill>
+              </a:rPr>
+              <a:t>$rankFusion</a:t>
+            </a:r>
+            <a:endParaRPr lang="en-US" sz="1100" dirty="0"/>
+          </a:p>
+        </p:txBody>
       </p:sp>
       <p:pic>
         <p:nvPicPr>
-          <p:cNvPr id="15" name="Feature icon 3" descr="Automated Embedding icon">    </p:cNvPr>
+          <p:cNvPr id="12" name="Pipeline arrow 3" descr="then">    </p:cNvPr>
           <p:cNvPicPr>
             <a:picLocks noChangeAspect="1"/>
           </p:cNvPicPr>
@@ -4743,8 +4711,8 @@
         </p:blipFill>
         <p:spPr>
           <a:xfrm>
-            <a:off x="813816" y="2724912"/>
-            <a:ext cx="219456" cy="219456"/>
+            <a:off x="5230368" y="1645920"/>
+            <a:ext cx="201168" cy="201168"/>
           </a:xfrm>
           <a:prstGeom prst="rect">
             <a:avLst/>
@@ -4753,121 +4721,79 @@
       </p:pic>
       <p:sp>
         <p:nvSpPr>
-          <p:cNvPr id="16" name="Feature name 3"/>
-          <p:cNvSpPr txBox="1"/>
-          <p:nvPr/>
-        </p:nvSpPr>
-        <p:spPr>
-          <a:xfrm>
-            <a:off x="1261872" y="2523744"/>
-            <a:ext cx="1965960" cy="292608"/>
-          </a:xfrm>
-          <a:prstGeom prst="rect">
-            <a:avLst/>
-          </a:prstGeom>
-          <a:noFill/>
-          <a:ln/>
-        </p:spPr>
-        <p:txBody>
-          <a:bodyPr wrap="square" lIns="0" tIns="0" rIns="0" bIns="0" rtlCol="0" anchor="ctr"/>
-          <a:lstStyle/>
-          <a:p>
-            <a:pPr indent="0" marL="0">
-              <a:buNone/>
-            </a:pPr>
-            <a:r>
-              <a:rPr lang="en-US" sz="1300" b="1" dirty="0">
-                <a:solidFill>
-                  <a:schemeClr val="tx1"/>
-                </a:solidFill>
-              </a:rPr>
-              <a:t>Automated Embedding</a:t>
-            </a:r>
-            <a:endParaRPr lang="en-US" sz="1300" dirty="0"/>
-          </a:p>
-        </p:txBody>
-      </p:sp>
-      <p:sp>
-        <p:nvSpPr>
-          <p:cNvPr id="17" name="Feature text 3"/>
-          <p:cNvSpPr txBox="1"/>
-          <p:nvPr/>
-        </p:nvSpPr>
-        <p:spPr>
-          <a:xfrm>
-            <a:off x="1261872" y="2816352"/>
-            <a:ext cx="1965960" cy="365760"/>
-          </a:xfrm>
-          <a:prstGeom prst="rect">
-            <a:avLst/>
-          </a:prstGeom>
-          <a:noFill/>
-          <a:ln/>
-        </p:spPr>
-        <p:txBody>
-          <a:bodyPr wrap="square" lIns="0" tIns="0" rIns="0" bIns="0" rtlCol="0" anchor="t"/>
-          <a:lstStyle/>
-          <a:p>
-            <a:pPr indent="0" marL="0">
-              <a:buNone/>
-            </a:pPr>
-            <a:r>
-              <a:rPr lang="en-US" sz="1100" dirty="0">
-                <a:solidFill>
-                  <a:schemeClr val="accent3"/>
-                </a:solidFill>
-              </a:rPr>
-              <a:t>Voyage voyage-4, embedded inside Atlas</a:t>
-            </a:r>
-            <a:endParaRPr lang="en-US" sz="1100" dirty="0"/>
-          </a:p>
-        </p:txBody>
-      </p:sp>
-      <p:sp>
-        <p:nvSpPr>
-          <p:cNvPr id="18" name="Feature card 4"/>
+          <p:cNvPr id="13" name="Pipeline step 4"/>
           <p:cNvSpPr/>
           <p:nvPr/>
         </p:nvSpPr>
         <p:spPr>
           <a:xfrm>
-            <a:off x="3429000" y="2377440"/>
-            <a:ext cx="2743200" cy="914400"/>
+            <a:off x="5486400" y="1463040"/>
+            <a:ext cx="1325880" cy="566928"/>
           </a:xfrm>
           <a:prstGeom prst="roundRect">
             <a:avLst>
-              <a:gd name="adj" fmla="val 10000"/>
+              <a:gd name="adj" fmla="val 16129"/>
             </a:avLst>
           </a:prstGeom>
           <a:solidFill>
-            <a:schemeClr val="bg2"/>
+            <a:schemeClr val="tx2"/>
           </a:solidFill>
           <a:ln/>
         </p:spPr>
       </p:sp>
       <p:sp>
         <p:nvSpPr>
-          <p:cNvPr id="19" name="Feature circle 4"/>
-          <p:cNvSpPr/>
-          <p:nvPr/>
-        </p:nvSpPr>
-        <p:spPr>
-          <a:xfrm>
-            <a:off x="3593592" y="2624328"/>
-            <a:ext cx="420624" cy="420624"/>
-          </a:xfrm>
-          <a:prstGeom prst="ellipse">
-            <a:avLst/>
-          </a:prstGeom>
-          <a:solidFill>
-            <a:schemeClr val="accent1"/>
-          </a:solidFill>
-          <a:ln/>
-        </p:spPr>
+          <p:cNvPr id="14" name="Pipeline label 4"/>
+          <p:cNvSpPr txBox="1"/>
+          <p:nvPr/>
+        </p:nvSpPr>
+        <p:spPr>
+          <a:xfrm>
+            <a:off x="5486400" y="1463040"/>
+            <a:ext cx="1325880" cy="566928"/>
+          </a:xfrm>
+          <a:prstGeom prst="rect">
+            <a:avLst/>
+          </a:prstGeom>
+          <a:noFill/>
+          <a:ln/>
+        </p:spPr>
+        <p:txBody>
+          <a:bodyPr wrap="square" lIns="0" tIns="0" rIns="0" bIns="0" rtlCol="0" anchor="ctr"/>
+          <a:lstStyle/>
+          <a:p>
+            <a:pPr algn="ctr" indent="0" marL="0">
+              <a:buNone/>
+            </a:pPr>
+            <a:r>
+              <a:rPr lang="en-US" sz="1100" b="1" dirty="0">
+                <a:solidFill>
+                  <a:schemeClr val="bg1"/>
+                </a:solidFill>
+              </a:rPr>
+              <a:t>Voyage</a:t>
+            </a:r>
+            <a:endParaRPr lang="en-US" sz="1100" dirty="0"/>
+          </a:p>
+          <a:p>
+            <a:pPr algn="ctr" indent="0" marL="0">
+              <a:buNone/>
+            </a:pPr>
+            <a:r>
+              <a:rPr lang="en-US" sz="1100" b="1" dirty="0">
+                <a:solidFill>
+                  <a:schemeClr val="bg1"/>
+                </a:solidFill>
+              </a:rPr>
+              <a:t>rerank</a:t>
+            </a:r>
+            <a:endParaRPr lang="en-US" sz="1100" dirty="0"/>
+          </a:p>
+        </p:txBody>
       </p:sp>
       <p:pic>
         <p:nvPicPr>
-          <p:cNvPr id="20" name="Feature icon 4" descr="Hybrid Search icon">    </p:cNvPr>
+          <p:cNvPr id="15" name="Pipeline arrow 4" descr="then">    </p:cNvPr>
           <p:cNvPicPr>
             <a:picLocks noChangeAspect="1"/>
           </p:cNvPicPr>
@@ -4881,8 +4807,8 @@
         </p:blipFill>
         <p:spPr>
           <a:xfrm>
-            <a:off x="3694176" y="2724912"/>
-            <a:ext cx="219456" cy="219456"/>
+            <a:off x="6876288" y="1645920"/>
+            <a:ext cx="201168" cy="201168"/>
           </a:xfrm>
           <a:prstGeom prst="rect">
             <a:avLst/>
@@ -4891,90 +4817,90 @@
       </p:pic>
       <p:sp>
         <p:nvSpPr>
-          <p:cNvPr id="21" name="Feature name 4"/>
-          <p:cNvSpPr txBox="1"/>
-          <p:nvPr/>
-        </p:nvSpPr>
-        <p:spPr>
-          <a:xfrm>
-            <a:off x="4142232" y="2523744"/>
-            <a:ext cx="1965960" cy="292608"/>
-          </a:xfrm>
-          <a:prstGeom prst="rect">
-            <a:avLst/>
-          </a:prstGeom>
-          <a:noFill/>
-          <a:ln/>
-        </p:spPr>
-        <p:txBody>
-          <a:bodyPr wrap="square" lIns="0" tIns="0" rIns="0" bIns="0" rtlCol="0" anchor="ctr"/>
-          <a:lstStyle/>
-          <a:p>
-            <a:pPr indent="0" marL="0">
-              <a:buNone/>
-            </a:pPr>
-            <a:r>
-              <a:rPr lang="en-US" sz="1300" b="1" dirty="0">
-                <a:solidFill>
-                  <a:schemeClr val="tx1"/>
-                </a:solidFill>
-              </a:rPr>
-              <a:t>Hybrid Search</a:t>
-            </a:r>
-            <a:endParaRPr lang="en-US" sz="1300" dirty="0"/>
-          </a:p>
-        </p:txBody>
-      </p:sp>
-      <p:sp>
-        <p:nvSpPr>
-          <p:cNvPr id="22" name="Feature text 4"/>
-          <p:cNvSpPr txBox="1"/>
-          <p:nvPr/>
-        </p:nvSpPr>
-        <p:spPr>
-          <a:xfrm>
-            <a:off x="4142232" y="2816352"/>
-            <a:ext cx="1965960" cy="365760"/>
-          </a:xfrm>
-          <a:prstGeom prst="rect">
-            <a:avLst/>
-          </a:prstGeom>
-          <a:noFill/>
-          <a:ln/>
-        </p:spPr>
-        <p:txBody>
-          <a:bodyPr wrap="square" lIns="0" tIns="0" rIns="0" bIns="0" rtlCol="0" anchor="t"/>
-          <a:lstStyle/>
-          <a:p>
-            <a:pPr indent="0" marL="0">
-              <a:buNone/>
-            </a:pPr>
-            <a:r>
-              <a:rPr lang="en-US" sz="1100" dirty="0">
-                <a:solidFill>
-                  <a:schemeClr val="accent3"/>
-                </a:solidFill>
-              </a:rPr>
-              <a:t>$rankFusion of text and vectors</a:t>
-            </a:r>
-            <a:endParaRPr lang="en-US" sz="1100" dirty="0"/>
-          </a:p>
-        </p:txBody>
-      </p:sp>
-      <p:sp>
-        <p:nvSpPr>
-          <p:cNvPr id="23" name="Feature card 5"/>
+          <p:cNvPr id="16" name="Pipeline step 5"/>
           <p:cNvSpPr/>
           <p:nvPr/>
         </p:nvSpPr>
         <p:spPr>
           <a:xfrm>
-            <a:off x="548640" y="3429000"/>
-            <a:ext cx="2743200" cy="914400"/>
+            <a:off x="7132320" y="1463040"/>
+            <a:ext cx="1325880" cy="566928"/>
           </a:xfrm>
           <a:prstGeom prst="roundRect">
             <a:avLst>
-              <a:gd name="adj" fmla="val 10000"/>
+              <a:gd name="adj" fmla="val 16129"/>
+            </a:avLst>
+          </a:prstGeom>
+          <a:solidFill>
+            <a:schemeClr val="accent1"/>
+          </a:solidFill>
+          <a:ln/>
+        </p:spPr>
+      </p:sp>
+      <p:sp>
+        <p:nvSpPr>
+          <p:cNvPr id="17" name="Pipeline label 5"/>
+          <p:cNvSpPr txBox="1"/>
+          <p:nvPr/>
+        </p:nvSpPr>
+        <p:spPr>
+          <a:xfrm>
+            <a:off x="7132320" y="1463040"/>
+            <a:ext cx="1325880" cy="566928"/>
+          </a:xfrm>
+          <a:prstGeom prst="rect">
+            <a:avLst/>
+          </a:prstGeom>
+          <a:noFill/>
+          <a:ln/>
+        </p:spPr>
+        <p:txBody>
+          <a:bodyPr wrap="square" lIns="0" tIns="0" rIns="0" bIns="0" rtlCol="0" anchor="ctr"/>
+          <a:lstStyle/>
+          <a:p>
+            <a:pPr algn="ctr" indent="0" marL="0">
+              <a:buNone/>
+            </a:pPr>
+            <a:r>
+              <a:rPr lang="en-US" sz="1100" b="1" dirty="0">
+                <a:solidFill>
+                  <a:schemeClr val="tx1"/>
+                </a:solidFill>
+              </a:rPr>
+              <a:t>Grounded</a:t>
+            </a:r>
+            <a:endParaRPr lang="en-US" sz="1100" dirty="0"/>
+          </a:p>
+          <a:p>
+            <a:pPr algn="ctr" indent="0" marL="0">
+              <a:buNone/>
+            </a:pPr>
+            <a:r>
+              <a:rPr lang="en-US" sz="1100" b="1" dirty="0">
+                <a:solidFill>
+                  <a:schemeClr val="tx1"/>
+                </a:solidFill>
+              </a:rPr>
+              <a:t>answer</a:t>
+            </a:r>
+            <a:endParaRPr lang="en-US" sz="1100" dirty="0"/>
+          </a:p>
+        </p:txBody>
+      </p:sp>
+      <p:sp>
+        <p:nvSpPr>
+          <p:cNvPr id="18" name="Feature card 1"/>
+          <p:cNvSpPr/>
+          <p:nvPr/>
+        </p:nvSpPr>
+        <p:spPr>
+          <a:xfrm>
+            <a:off x="548640" y="2286000"/>
+            <a:ext cx="2743200" cy="640080"/>
+          </a:xfrm>
+          <a:prstGeom prst="roundRect">
+            <a:avLst>
+              <a:gd name="adj" fmla="val 14286"/>
             </a:avLst>
           </a:prstGeom>
           <a:solidFill>
@@ -4985,14 +4911,14 @@
       </p:sp>
       <p:sp>
         <p:nvSpPr>
-          <p:cNvPr id="24" name="Feature circle 5"/>
+          <p:cNvPr id="19" name="Feature circle 1"/>
           <p:cNvSpPr/>
           <p:nvPr/>
         </p:nvSpPr>
         <p:spPr>
           <a:xfrm>
-            <a:off x="713232" y="3675888"/>
-            <a:ext cx="420624" cy="420624"/>
+            <a:off x="685800" y="2414016"/>
+            <a:ext cx="384048" cy="384048"/>
           </a:xfrm>
           <a:prstGeom prst="ellipse">
             <a:avLst/>
@@ -5005,7 +4931,7 @@
       </p:sp>
       <p:pic>
         <p:nvPicPr>
-          <p:cNvPr id="25" name="Feature icon 5" descr="Voyage AI Rerank icon">    </p:cNvPr>
+          <p:cNvPr id="20" name="Feature icon 1" descr="Atlas Search icon">    </p:cNvPr>
           <p:cNvPicPr>
             <a:picLocks noChangeAspect="1"/>
           </p:cNvPicPr>
@@ -5019,8 +4945,8 @@
         </p:blipFill>
         <p:spPr>
           <a:xfrm>
-            <a:off x="813816" y="3776472"/>
-            <a:ext cx="219456" cy="219456"/>
+            <a:off x="781812" y="2510028"/>
+            <a:ext cx="192024" cy="192024"/>
           </a:xfrm>
           <a:prstGeom prst="rect">
             <a:avLst/>
@@ -5029,14 +4955,14 @@
       </p:pic>
       <p:sp>
         <p:nvSpPr>
-          <p:cNvPr id="26" name="Feature name 5"/>
+          <p:cNvPr id="21" name="Feature name 1"/>
           <p:cNvSpPr txBox="1"/>
           <p:nvPr/>
         </p:nvSpPr>
         <p:spPr>
           <a:xfrm>
-            <a:off x="1261872" y="3575304"/>
-            <a:ext cx="1965960" cy="292608"/>
+            <a:off x="1188720" y="2359152"/>
+            <a:ext cx="2057400" cy="256032"/>
           </a:xfrm>
           <a:prstGeom prst="rect">
             <a:avLst/>
@@ -5057,7 +4983,7 @@
                   <a:schemeClr val="tx1"/>
                 </a:solidFill>
               </a:rPr>
-              <a:t>Voyage AI Rerank</a:t>
+              <a:t>Atlas Search</a:t>
             </a:r>
             <a:endParaRPr lang="en-US" sz="1300" dirty="0"/>
           </a:p>
@@ -5065,23 +4991,23 @@
       </p:sp>
       <p:sp>
         <p:nvSpPr>
-          <p:cNvPr id="27" name="Feature text 5"/>
+          <p:cNvPr id="22" name="Feature text 1"/>
           <p:cNvSpPr txBox="1"/>
           <p:nvPr/>
         </p:nvSpPr>
         <p:spPr>
           <a:xfrm>
-            <a:off x="1261872" y="3867912"/>
-            <a:ext cx="1965960" cy="365760"/>
-          </a:xfrm>
-          <a:prstGeom prst="rect">
-            <a:avLst/>
-          </a:prstGeom>
-          <a:noFill/>
-          <a:ln/>
-        </p:spPr>
-        <p:txBody>
-          <a:bodyPr wrap="square" lIns="0" tIns="0" rIns="0" bIns="0" rtlCol="0" anchor="t"/>
+            <a:off x="1188720" y="2615184"/>
+            <a:ext cx="2057400" cy="237744"/>
+          </a:xfrm>
+          <a:prstGeom prst="rect">
+            <a:avLst/>
+          </a:prstGeom>
+          <a:noFill/>
+          <a:ln/>
+        </p:spPr>
+        <p:txBody>
+          <a:bodyPr wrap="square" lIns="0" tIns="0" rIns="0" bIns="0" rtlCol="0" anchor="ctr"/>
           <a:lstStyle/>
           <a:p>
             <a:pPr indent="0" marL="0">
@@ -5093,7 +5019,7 @@
                   <a:schemeClr val="accent3"/>
                 </a:solidFill>
               </a:rPr>
-              <a:t>rerank-2.5 on the fused results</a:t>
+              <a:t>Exact words: prawn, gluten</a:t>
             </a:r>
             <a:endParaRPr lang="en-US" sz="1100" dirty="0"/>
           </a:p>
@@ -5101,18 +5027,18 @@
       </p:sp>
       <p:sp>
         <p:nvSpPr>
-          <p:cNvPr id="28" name="Feature card 6"/>
+          <p:cNvPr id="23" name="Feature card 2"/>
           <p:cNvSpPr/>
           <p:nvPr/>
         </p:nvSpPr>
         <p:spPr>
           <a:xfrm>
-            <a:off x="3429000" y="3429000"/>
-            <a:ext cx="2743200" cy="914400"/>
+            <a:off x="3429000" y="2286000"/>
+            <a:ext cx="2743200" cy="640080"/>
           </a:xfrm>
           <a:prstGeom prst="roundRect">
             <a:avLst>
-              <a:gd name="adj" fmla="val 10000"/>
+              <a:gd name="adj" fmla="val 14286"/>
             </a:avLst>
           </a:prstGeom>
           <a:solidFill>
@@ -5123,14 +5049,14 @@
       </p:sp>
       <p:sp>
         <p:nvSpPr>
-          <p:cNvPr id="29" name="Feature circle 6"/>
+          <p:cNvPr id="24" name="Feature circle 2"/>
           <p:cNvSpPr/>
           <p:nvPr/>
         </p:nvSpPr>
         <p:spPr>
           <a:xfrm>
-            <a:off x="3593592" y="3675888"/>
-            <a:ext cx="420624" cy="420624"/>
+            <a:off x="3566160" y="2414016"/>
+            <a:ext cx="384048" cy="384048"/>
           </a:xfrm>
           <a:prstGeom prst="ellipse">
             <a:avLst/>
@@ -5143,7 +5069,7 @@
       </p:sp>
       <p:pic>
         <p:nvPicPr>
-          <p:cNvPr id="30" name="Feature icon 6" descr="Stream Processing icon">    </p:cNvPr>
+          <p:cNvPr id="25" name="Feature icon 2" descr="Vector Search icon">    </p:cNvPr>
           <p:cNvPicPr>
             <a:picLocks noChangeAspect="1"/>
           </p:cNvPicPr>
@@ -5157,8 +5083,8 @@
         </p:blipFill>
         <p:spPr>
           <a:xfrm>
-            <a:off x="3694176" y="3776472"/>
-            <a:ext cx="219456" cy="219456"/>
+            <a:off x="3662172" y="2510028"/>
+            <a:ext cx="192024" cy="192024"/>
           </a:xfrm>
           <a:prstGeom prst="rect">
             <a:avLst/>
@@ -5167,14 +5093,14 @@
       </p:pic>
       <p:sp>
         <p:nvSpPr>
-          <p:cNvPr id="31" name="Feature name 6"/>
+          <p:cNvPr id="26" name="Feature name 2"/>
           <p:cNvSpPr txBox="1"/>
           <p:nvPr/>
         </p:nvSpPr>
         <p:spPr>
           <a:xfrm>
-            <a:off x="4142232" y="3575304"/>
-            <a:ext cx="1965960" cy="292608"/>
+            <a:off x="4069080" y="2359152"/>
+            <a:ext cx="2057400" cy="256032"/>
           </a:xfrm>
           <a:prstGeom prst="rect">
             <a:avLst/>
@@ -5195,6 +5121,558 @@
                   <a:schemeClr val="tx1"/>
                 </a:solidFill>
               </a:rPr>
+              <a:t>Vector Search</a:t>
+            </a:r>
+            <a:endParaRPr lang="en-US" sz="1300" dirty="0"/>
+          </a:p>
+        </p:txBody>
+      </p:sp>
+      <p:sp>
+        <p:nvSpPr>
+          <p:cNvPr id="27" name="Feature text 2"/>
+          <p:cNvSpPr txBox="1"/>
+          <p:nvPr/>
+        </p:nvSpPr>
+        <p:spPr>
+          <a:xfrm>
+            <a:off x="4069080" y="2615184"/>
+            <a:ext cx="2057400" cy="237744"/>
+          </a:xfrm>
+          <a:prstGeom prst="rect">
+            <a:avLst/>
+          </a:prstGeom>
+          <a:noFill/>
+          <a:ln/>
+        </p:spPr>
+        <p:txBody>
+          <a:bodyPr wrap="square" lIns="0" tIns="0" rIns="0" bIns="0" rtlCol="0" anchor="ctr"/>
+          <a:lstStyle/>
+          <a:p>
+            <a:pPr indent="0" marL="0">
+              <a:buNone/>
+            </a:pPr>
+            <a:r>
+              <a:rPr lang="en-US" sz="1100" dirty="0">
+                <a:solidFill>
+                  <a:schemeClr val="accent3"/>
+                </a:solidFill>
+              </a:rPr>
+              <a:t>Finds dishes by meaning</a:t>
+            </a:r>
+            <a:endParaRPr lang="en-US" sz="1100" dirty="0"/>
+          </a:p>
+        </p:txBody>
+      </p:sp>
+      <p:sp>
+        <p:nvSpPr>
+          <p:cNvPr id="28" name="Feature card 3"/>
+          <p:cNvSpPr/>
+          <p:nvPr/>
+        </p:nvSpPr>
+        <p:spPr>
+          <a:xfrm>
+            <a:off x="548640" y="3035808"/>
+            <a:ext cx="2743200" cy="640080"/>
+          </a:xfrm>
+          <a:prstGeom prst="roundRect">
+            <a:avLst>
+              <a:gd name="adj" fmla="val 14286"/>
+            </a:avLst>
+          </a:prstGeom>
+          <a:solidFill>
+            <a:schemeClr val="bg2"/>
+          </a:solidFill>
+          <a:ln/>
+        </p:spPr>
+      </p:sp>
+      <p:sp>
+        <p:nvSpPr>
+          <p:cNvPr id="29" name="Feature circle 3"/>
+          <p:cNvSpPr/>
+          <p:nvPr/>
+        </p:nvSpPr>
+        <p:spPr>
+          <a:xfrm>
+            <a:off x="685800" y="3163824"/>
+            <a:ext cx="384048" cy="384048"/>
+          </a:xfrm>
+          <a:prstGeom prst="ellipse">
+            <a:avLst/>
+          </a:prstGeom>
+          <a:solidFill>
+            <a:schemeClr val="accent1"/>
+          </a:solidFill>
+          <a:ln/>
+        </p:spPr>
+      </p:sp>
+      <p:pic>
+        <p:nvPicPr>
+          <p:cNvPr id="30" name="Feature icon 3" descr="Automated Embedding icon">    </p:cNvPr>
+          <p:cNvPicPr>
+            <a:picLocks noChangeAspect="1"/>
+          </p:cNvPicPr>
+          <p:nvPr/>
+        </p:nvPicPr>
+        <p:blipFill>
+          <a:blip r:embed="rId7"/>
+          <a:stretch>
+            <a:fillRect/>
+          </a:stretch>
+        </p:blipFill>
+        <p:spPr>
+          <a:xfrm>
+            <a:off x="781812" y="3259836"/>
+            <a:ext cx="192024" cy="192024"/>
+          </a:xfrm>
+          <a:prstGeom prst="rect">
+            <a:avLst/>
+          </a:prstGeom>
+        </p:spPr>
+      </p:pic>
+      <p:sp>
+        <p:nvSpPr>
+          <p:cNvPr id="31" name="Feature name 3"/>
+          <p:cNvSpPr txBox="1"/>
+          <p:nvPr/>
+        </p:nvSpPr>
+        <p:spPr>
+          <a:xfrm>
+            <a:off x="1188720" y="3108960"/>
+            <a:ext cx="2057400" cy="256032"/>
+          </a:xfrm>
+          <a:prstGeom prst="rect">
+            <a:avLst/>
+          </a:prstGeom>
+          <a:noFill/>
+          <a:ln/>
+        </p:spPr>
+        <p:txBody>
+          <a:bodyPr wrap="square" lIns="0" tIns="0" rIns="0" bIns="0" rtlCol="0" anchor="ctr"/>
+          <a:lstStyle/>
+          <a:p>
+            <a:pPr indent="0" marL="0">
+              <a:buNone/>
+            </a:pPr>
+            <a:r>
+              <a:rPr lang="en-US" sz="1300" b="1" dirty="0">
+                <a:solidFill>
+                  <a:schemeClr val="tx1"/>
+                </a:solidFill>
+              </a:rPr>
+              <a:t>Automated Embedding</a:t>
+            </a:r>
+            <a:endParaRPr lang="en-US" sz="1300" dirty="0"/>
+          </a:p>
+        </p:txBody>
+      </p:sp>
+      <p:sp>
+        <p:nvSpPr>
+          <p:cNvPr id="32" name="Feature text 3"/>
+          <p:cNvSpPr txBox="1"/>
+          <p:nvPr/>
+        </p:nvSpPr>
+        <p:spPr>
+          <a:xfrm>
+            <a:off x="1188720" y="3364992"/>
+            <a:ext cx="2057400" cy="237744"/>
+          </a:xfrm>
+          <a:prstGeom prst="rect">
+            <a:avLst/>
+          </a:prstGeom>
+          <a:noFill/>
+          <a:ln/>
+        </p:spPr>
+        <p:txBody>
+          <a:bodyPr wrap="square" lIns="0" tIns="0" rIns="0" bIns="0" rtlCol="0" anchor="ctr"/>
+          <a:lstStyle/>
+          <a:p>
+            <a:pPr indent="0" marL="0">
+              <a:buNone/>
+            </a:pPr>
+            <a:r>
+              <a:rPr lang="en-US" sz="1100" dirty="0">
+                <a:solidFill>
+                  <a:schemeClr val="accent3"/>
+                </a:solidFill>
+              </a:rPr>
+              <a:t>Atlas embeds every dish itself</a:t>
+            </a:r>
+            <a:endParaRPr lang="en-US" sz="1100" dirty="0"/>
+          </a:p>
+        </p:txBody>
+      </p:sp>
+      <p:sp>
+        <p:nvSpPr>
+          <p:cNvPr id="33" name="Feature card 4"/>
+          <p:cNvSpPr/>
+          <p:nvPr/>
+        </p:nvSpPr>
+        <p:spPr>
+          <a:xfrm>
+            <a:off x="3429000" y="3035808"/>
+            <a:ext cx="2743200" cy="640080"/>
+          </a:xfrm>
+          <a:prstGeom prst="roundRect">
+            <a:avLst>
+              <a:gd name="adj" fmla="val 14286"/>
+            </a:avLst>
+          </a:prstGeom>
+          <a:solidFill>
+            <a:schemeClr val="bg2"/>
+          </a:solidFill>
+          <a:ln/>
+        </p:spPr>
+      </p:sp>
+      <p:sp>
+        <p:nvSpPr>
+          <p:cNvPr id="34" name="Feature circle 4"/>
+          <p:cNvSpPr/>
+          <p:nvPr/>
+        </p:nvSpPr>
+        <p:spPr>
+          <a:xfrm>
+            <a:off x="3566160" y="3163824"/>
+            <a:ext cx="384048" cy="384048"/>
+          </a:xfrm>
+          <a:prstGeom prst="ellipse">
+            <a:avLst/>
+          </a:prstGeom>
+          <a:solidFill>
+            <a:schemeClr val="accent1"/>
+          </a:solidFill>
+          <a:ln/>
+        </p:spPr>
+      </p:sp>
+      <p:pic>
+        <p:nvPicPr>
+          <p:cNvPr id="35" name="Feature icon 4" descr="Hybrid Search icon">    </p:cNvPr>
+          <p:cNvPicPr>
+            <a:picLocks noChangeAspect="1"/>
+          </p:cNvPicPr>
+          <p:nvPr/>
+        </p:nvPicPr>
+        <p:blipFill>
+          <a:blip r:embed="rId8"/>
+          <a:stretch>
+            <a:fillRect/>
+          </a:stretch>
+        </p:blipFill>
+        <p:spPr>
+          <a:xfrm>
+            <a:off x="3662172" y="3259836"/>
+            <a:ext cx="192024" cy="192024"/>
+          </a:xfrm>
+          <a:prstGeom prst="rect">
+            <a:avLst/>
+          </a:prstGeom>
+        </p:spPr>
+      </p:pic>
+      <p:sp>
+        <p:nvSpPr>
+          <p:cNvPr id="36" name="Feature name 4"/>
+          <p:cNvSpPr txBox="1"/>
+          <p:nvPr/>
+        </p:nvSpPr>
+        <p:spPr>
+          <a:xfrm>
+            <a:off x="4069080" y="3108960"/>
+            <a:ext cx="2057400" cy="256032"/>
+          </a:xfrm>
+          <a:prstGeom prst="rect">
+            <a:avLst/>
+          </a:prstGeom>
+          <a:noFill/>
+          <a:ln/>
+        </p:spPr>
+        <p:txBody>
+          <a:bodyPr wrap="square" lIns="0" tIns="0" rIns="0" bIns="0" rtlCol="0" anchor="ctr"/>
+          <a:lstStyle/>
+          <a:p>
+            <a:pPr indent="0" marL="0">
+              <a:buNone/>
+            </a:pPr>
+            <a:r>
+              <a:rPr lang="en-US" sz="1300" b="1" dirty="0">
+                <a:solidFill>
+                  <a:schemeClr val="tx1"/>
+                </a:solidFill>
+              </a:rPr>
+              <a:t>Hybrid Search</a:t>
+            </a:r>
+            <a:endParaRPr lang="en-US" sz="1300" dirty="0"/>
+          </a:p>
+        </p:txBody>
+      </p:sp>
+      <p:sp>
+        <p:nvSpPr>
+          <p:cNvPr id="37" name="Feature text 4"/>
+          <p:cNvSpPr txBox="1"/>
+          <p:nvPr/>
+        </p:nvSpPr>
+        <p:spPr>
+          <a:xfrm>
+            <a:off x="4069080" y="3364992"/>
+            <a:ext cx="2057400" cy="237744"/>
+          </a:xfrm>
+          <a:prstGeom prst="rect">
+            <a:avLst/>
+          </a:prstGeom>
+          <a:noFill/>
+          <a:ln/>
+        </p:spPr>
+        <p:txBody>
+          <a:bodyPr wrap="square" lIns="0" tIns="0" rIns="0" bIns="0" rtlCol="0" anchor="ctr"/>
+          <a:lstStyle/>
+          <a:p>
+            <a:pPr indent="0" marL="0">
+              <a:buNone/>
+            </a:pPr>
+            <a:r>
+              <a:rPr lang="en-US" sz="1100" dirty="0">
+                <a:solidFill>
+                  <a:schemeClr val="accent3"/>
+                </a:solidFill>
+              </a:rPr>
+              <a:t>$rankFusion, allergens out</a:t>
+            </a:r>
+            <a:endParaRPr lang="en-US" sz="1100" dirty="0"/>
+          </a:p>
+        </p:txBody>
+      </p:sp>
+      <p:sp>
+        <p:nvSpPr>
+          <p:cNvPr id="38" name="Feature card 5"/>
+          <p:cNvSpPr/>
+          <p:nvPr/>
+        </p:nvSpPr>
+        <p:spPr>
+          <a:xfrm>
+            <a:off x="548640" y="3785616"/>
+            <a:ext cx="2743200" cy="640080"/>
+          </a:xfrm>
+          <a:prstGeom prst="roundRect">
+            <a:avLst>
+              <a:gd name="adj" fmla="val 14286"/>
+            </a:avLst>
+          </a:prstGeom>
+          <a:solidFill>
+            <a:schemeClr val="bg2"/>
+          </a:solidFill>
+          <a:ln/>
+        </p:spPr>
+      </p:sp>
+      <p:sp>
+        <p:nvSpPr>
+          <p:cNvPr id="39" name="Feature circle 5"/>
+          <p:cNvSpPr/>
+          <p:nvPr/>
+        </p:nvSpPr>
+        <p:spPr>
+          <a:xfrm>
+            <a:off x="685800" y="3913632"/>
+            <a:ext cx="384048" cy="384048"/>
+          </a:xfrm>
+          <a:prstGeom prst="ellipse">
+            <a:avLst/>
+          </a:prstGeom>
+          <a:solidFill>
+            <a:schemeClr val="accent1"/>
+          </a:solidFill>
+          <a:ln/>
+        </p:spPr>
+      </p:sp>
+      <p:pic>
+        <p:nvPicPr>
+          <p:cNvPr id="40" name="Feature icon 5" descr="Voyage AI Rerank icon">    </p:cNvPr>
+          <p:cNvPicPr>
+            <a:picLocks noChangeAspect="1"/>
+          </p:cNvPicPr>
+          <p:nvPr/>
+        </p:nvPicPr>
+        <p:blipFill>
+          <a:blip r:embed="rId9"/>
+          <a:stretch>
+            <a:fillRect/>
+          </a:stretch>
+        </p:blipFill>
+        <p:spPr>
+          <a:xfrm>
+            <a:off x="781812" y="4009644"/>
+            <a:ext cx="192024" cy="192024"/>
+          </a:xfrm>
+          <a:prstGeom prst="rect">
+            <a:avLst/>
+          </a:prstGeom>
+        </p:spPr>
+      </p:pic>
+      <p:sp>
+        <p:nvSpPr>
+          <p:cNvPr id="41" name="Feature name 5"/>
+          <p:cNvSpPr txBox="1"/>
+          <p:nvPr/>
+        </p:nvSpPr>
+        <p:spPr>
+          <a:xfrm>
+            <a:off x="1188720" y="3858768"/>
+            <a:ext cx="2057400" cy="256032"/>
+          </a:xfrm>
+          <a:prstGeom prst="rect">
+            <a:avLst/>
+          </a:prstGeom>
+          <a:noFill/>
+          <a:ln/>
+        </p:spPr>
+        <p:txBody>
+          <a:bodyPr wrap="square" lIns="0" tIns="0" rIns="0" bIns="0" rtlCol="0" anchor="ctr"/>
+          <a:lstStyle/>
+          <a:p>
+            <a:pPr indent="0" marL="0">
+              <a:buNone/>
+            </a:pPr>
+            <a:r>
+              <a:rPr lang="en-US" sz="1300" b="1" dirty="0">
+                <a:solidFill>
+                  <a:schemeClr val="tx1"/>
+                </a:solidFill>
+              </a:rPr>
+              <a:t>Voyage AI Rerank</a:t>
+            </a:r>
+            <a:endParaRPr lang="en-US" sz="1300" dirty="0"/>
+          </a:p>
+        </p:txBody>
+      </p:sp>
+      <p:sp>
+        <p:nvSpPr>
+          <p:cNvPr id="42" name="Feature text 5"/>
+          <p:cNvSpPr txBox="1"/>
+          <p:nvPr/>
+        </p:nvSpPr>
+        <p:spPr>
+          <a:xfrm>
+            <a:off x="1188720" y="4114800"/>
+            <a:ext cx="2057400" cy="237744"/>
+          </a:xfrm>
+          <a:prstGeom prst="rect">
+            <a:avLst/>
+          </a:prstGeom>
+          <a:noFill/>
+          <a:ln/>
+        </p:spPr>
+        <p:txBody>
+          <a:bodyPr wrap="square" lIns="0" tIns="0" rIns="0" bIns="0" rtlCol="0" anchor="ctr"/>
+          <a:lstStyle/>
+          <a:p>
+            <a:pPr indent="0" marL="0">
+              <a:buNone/>
+            </a:pPr>
+            <a:r>
+              <a:rPr lang="en-US" sz="1100" dirty="0">
+                <a:solidFill>
+                  <a:schemeClr val="accent3"/>
+                </a:solidFill>
+              </a:rPr>
+              <a:t>rerank-2.5 puts the best first</a:t>
+            </a:r>
+            <a:endParaRPr lang="en-US" sz="1100" dirty="0"/>
+          </a:p>
+        </p:txBody>
+      </p:sp>
+      <p:sp>
+        <p:nvSpPr>
+          <p:cNvPr id="43" name="Feature card 6"/>
+          <p:cNvSpPr/>
+          <p:nvPr/>
+        </p:nvSpPr>
+        <p:spPr>
+          <a:xfrm>
+            <a:off x="3429000" y="3785616"/>
+            <a:ext cx="2743200" cy="640080"/>
+          </a:xfrm>
+          <a:prstGeom prst="roundRect">
+            <a:avLst>
+              <a:gd name="adj" fmla="val 14286"/>
+            </a:avLst>
+          </a:prstGeom>
+          <a:solidFill>
+            <a:schemeClr val="bg2"/>
+          </a:solidFill>
+          <a:ln/>
+        </p:spPr>
+      </p:sp>
+      <p:sp>
+        <p:nvSpPr>
+          <p:cNvPr id="44" name="Feature circle 6"/>
+          <p:cNvSpPr/>
+          <p:nvPr/>
+        </p:nvSpPr>
+        <p:spPr>
+          <a:xfrm>
+            <a:off x="3566160" y="3913632"/>
+            <a:ext cx="384048" cy="384048"/>
+          </a:xfrm>
+          <a:prstGeom prst="ellipse">
+            <a:avLst/>
+          </a:prstGeom>
+          <a:solidFill>
+            <a:schemeClr val="accent1"/>
+          </a:solidFill>
+          <a:ln/>
+        </p:spPr>
+      </p:sp>
+      <p:pic>
+        <p:nvPicPr>
+          <p:cNvPr id="45" name="Feature icon 6" descr="Stream Processing icon">    </p:cNvPr>
+          <p:cNvPicPr>
+            <a:picLocks noChangeAspect="1"/>
+          </p:cNvPicPr>
+          <p:nvPr/>
+        </p:nvPicPr>
+        <p:blipFill>
+          <a:blip r:embed="rId10"/>
+          <a:stretch>
+            <a:fillRect/>
+          </a:stretch>
+        </p:blipFill>
+        <p:spPr>
+          <a:xfrm>
+            <a:off x="3662172" y="4009644"/>
+            <a:ext cx="192024" cy="192024"/>
+          </a:xfrm>
+          <a:prstGeom prst="rect">
+            <a:avLst/>
+          </a:prstGeom>
+        </p:spPr>
+      </p:pic>
+      <p:sp>
+        <p:nvSpPr>
+          <p:cNvPr id="46" name="Feature name 6"/>
+          <p:cNvSpPr txBox="1"/>
+          <p:nvPr/>
+        </p:nvSpPr>
+        <p:spPr>
+          <a:xfrm>
+            <a:off x="4069080" y="3858768"/>
+            <a:ext cx="2057400" cy="256032"/>
+          </a:xfrm>
+          <a:prstGeom prst="rect">
+            <a:avLst/>
+          </a:prstGeom>
+          <a:noFill/>
+          <a:ln/>
+        </p:spPr>
+        <p:txBody>
+          <a:bodyPr wrap="square" lIns="0" tIns="0" rIns="0" bIns="0" rtlCol="0" anchor="ctr"/>
+          <a:lstStyle/>
+          <a:p>
+            <a:pPr indent="0" marL="0">
+              <a:buNone/>
+            </a:pPr>
+            <a:r>
+              <a:rPr lang="en-US" sz="1300" b="1" dirty="0">
+                <a:solidFill>
+                  <a:schemeClr val="tx1"/>
+                </a:solidFill>
+              </a:rPr>
               <a:t>Stream Processing</a:t>
             </a:r>
             <a:endParaRPr lang="en-US" sz="1300" dirty="0"/>
@@ -5203,23 +5681,23 @@
       </p:sp>
       <p:sp>
         <p:nvSpPr>
-          <p:cNvPr id="32" name="Feature text 6"/>
+          <p:cNvPr id="47" name="Feature text 6"/>
           <p:cNvSpPr txBox="1"/>
           <p:nvPr/>
         </p:nvSpPr>
         <p:spPr>
           <a:xfrm>
-            <a:off x="4142232" y="3867912"/>
-            <a:ext cx="1965960" cy="365760"/>
-          </a:xfrm>
-          <a:prstGeom prst="rect">
-            <a:avLst/>
-          </a:prstGeom>
-          <a:noFill/>
-          <a:ln/>
-        </p:spPr>
-        <p:txBody>
-          <a:bodyPr wrap="square" lIns="0" tIns="0" rIns="0" bIns="0" rtlCol="0" anchor="t"/>
+            <a:off x="4069080" y="4114800"/>
+            <a:ext cx="2057400" cy="237744"/>
+          </a:xfrm>
+          <a:prstGeom prst="rect">
+            <a:avLst/>
+          </a:prstGeom>
+          <a:noFill/>
+          <a:ln/>
+        </p:spPr>
+        <p:txBody>
+          <a:bodyPr wrap="square" lIns="0" tIns="0" rIns="0" bIns="0" rtlCol="0" anchor="ctr"/>
           <a:lstStyle/>
           <a:p>
             <a:pPr indent="0" marL="0">
@@ -5231,7 +5709,7 @@
                   <a:schemeClr val="accent3"/>
                 </a:solidFill>
               </a:rPr>
-              <a:t>Menu photos as an event stream (next)</a:t>
+              <a:t>Menu photos as events (next)</a:t>
             </a:r>
             <a:endParaRPr lang="en-US" sz="1100" dirty="0"/>
           </a:p>
@@ -5239,14 +5717,14 @@
       </p:sp>
       <p:sp>
         <p:nvSpPr>
-          <p:cNvPr id="33" name="Dish count"/>
+          <p:cNvPr id="48" name="Dish count"/>
           <p:cNvSpPr txBox="1"/>
           <p:nvPr/>
         </p:nvSpPr>
         <p:spPr>
           <a:xfrm>
-            <a:off x="6492240" y="1325880"/>
-            <a:ext cx="2286000" cy="868680"/>
+            <a:off x="6492240" y="2240280"/>
+            <a:ext cx="2103120" cy="777240"/>
           </a:xfrm>
           <a:prstGeom prst="rect">
             <a:avLst/>
@@ -5262,7 +5740,7 @@
               <a:buNone/>
             </a:pPr>
             <a:r>
-              <a:rPr lang="en-US" sz="5400" b="1" dirty="0">
+              <a:rPr lang="en-US" sz="4800" b="1" dirty="0">
                 <a:solidFill>
                   <a:schemeClr val="tx2"/>
                 </a:solidFill>
@@ -5272,20 +5750,20 @@
               </a:rPr>
               <a:t>750+</a:t>
             </a:r>
-            <a:endParaRPr lang="en-US" sz="5400" dirty="0"/>
-          </a:p>
-        </p:txBody>
-      </p:sp>
-      <p:sp>
-        <p:nvSpPr>
-          <p:cNvPr id="34" name="Dish count label"/>
+            <a:endParaRPr lang="en-US" sz="4800" dirty="0"/>
+          </a:p>
+        </p:txBody>
+      </p:sp>
+      <p:sp>
+        <p:nvSpPr>
+          <p:cNvPr id="49" name="Dish count label"/>
           <p:cNvSpPr txBox="1"/>
           <p:nvPr/>
         </p:nvSpPr>
         <p:spPr>
           <a:xfrm>
-            <a:off x="6492240" y="2194560"/>
-            <a:ext cx="2103120" cy="548640"/>
+            <a:off x="6492240" y="3017520"/>
+            <a:ext cx="2103120" cy="502920"/>
           </a:xfrm>
           <a:prstGeom prst="rect">
             <a:avLst/>
@@ -5314,14 +5792,14 @@
       </p:sp>
       <p:sp>
         <p:nvSpPr>
-          <p:cNvPr id="35" name="Shared knowledge note"/>
+          <p:cNvPr id="50" name="Shared knowledge note"/>
           <p:cNvSpPr txBox="1"/>
           <p:nvPr/>
         </p:nvSpPr>
         <p:spPr>
           <a:xfrm>
-            <a:off x="6492240" y="2926080"/>
-            <a:ext cx="2103120" cy="1371600"/>
+            <a:off x="6492240" y="3611880"/>
+            <a:ext cx="2103120" cy="777240"/>
           </a:xfrm>
           <a:prstGeom prst="rect">
             <a:avLst/>
@@ -5342,7 +5820,7 @@
                   <a:schemeClr val="tx2"/>
                 </a:solidFill>
               </a:rPr>
-              <a:t>Every menu one person reads makes the next search smarter. Nobody's allergies are stored, only knowledge about places.</a:t>
+              <a:t>Every menu one person reads makes the next search smarter.</a:t>
             </a:r>
             <a:endParaRPr lang="en-US" sz="1400" dirty="0"/>
           </a:p>

</xml_diff>

<commit_message>
Pitch: add MongoDB features-in-code slide, correct dish count
</commit_message>
<xml_diff>
--- a/pitch/MrMunch.pptx
+++ b/pitch/MrMunch.pptx
@@ -12,9 +12,10 @@
     <p:sldId id="260" r:id="rId6"/>
     <p:sldId id="261" r:id="rId7"/>
     <p:sldId id="262" r:id="rId8"/>
+    <p:sldId id="263" r:id="rId9"/>
   </p:sldIdLst>
   <p:notesMasterIdLst>
-    <p:notesMasterId r:id="rId9"/>
+    <p:notesMasterId r:id="rId10"/>
   </p:notesMasterIdLst>
   <p:sldSz cx="9144000" cy="5143500"/>
   <p:notesSz cx="5143500" cy="9144000"/>
@@ -113,39 +114,40 @@
   <p:extLst>
     <p:ext uri="{521415D9-36F7-43E2-AB2F-B90AF26B5E84}">
       <p14:sectionLst xmlns:p14="http://schemas.microsoft.com/office/powerpoint/2010/main">
-        <p14:section name="Intro" id="{e0952755-9d45-b05b-9020-d65682e3f872}">
+        <p14:section name="Intro" id="{3a282fb4-faad-2726-9a67-9df5370fb016}">
           <p14:sldIdLst>
             <p14:sldId id="256"/>
           </p14:sldIdLst>
         </p14:section>
-        <p14:section name="Problem" id="{90f5c36d-dadc-589e-9eb3-93b69b2ad43b}">
+        <p14:section name="Problem" id="{a780d5ad-2e0c-453b-c95c-54207f2dd115}">
           <p14:sldIdLst>
             <p14:sldId id="257"/>
           </p14:sldIdLst>
         </p14:section>
-        <p14:section name="Solution" id="{df824840-d7e3-0857-6f34-45cc9dad52b0}">
+        <p14:section name="Solution" id="{e1cb41b4-a98d-6843-0db7-23bd5ac45111}">
           <p14:sldIdLst>
             <p14:sldId id="258"/>
           </p14:sldIdLst>
         </p14:section>
-        <p14:section name="Demo" id="{bce3b1c1-877f-1e3e-f2a7-21c4bb62029e}">
+        <p14:section name="Demo" id="{8dbd1437-4686-27c1-09f9-795f4a20833b}">
           <p14:sldIdLst>
             <p14:sldId id="259"/>
           </p14:sldIdLst>
         </p14:section>
-        <p14:section name="MongoDB Atlas" id="{80e9cbfe-fd08-8b17-c2b2-c01c5f2e42f0}">
+        <p14:section name="MongoDB Atlas" id="{cc822817-1f8e-78f5-69a8-e56184cbaee1}">
           <p14:sldIdLst>
             <p14:sldId id="260"/>
-          </p14:sldIdLst>
-        </p14:section>
-        <p14:section name="Trust" id="{9abe7f85-9513-3a20-bfb0-d65a15c4b5b9}">
-          <p14:sldIdLst>
             <p14:sldId id="261"/>
           </p14:sldIdLst>
         </p14:section>
-        <p14:section name="Close" id="{71412cd2-3e94-a151-b43b-b62b4bea013f}">
+        <p14:section name="Trust" id="{36cd613f-2297-5094-be4e-fc15da152cfe}">
           <p14:sldIdLst>
             <p14:sldId id="262"/>
+          </p14:sldIdLst>
+        </p14:section>
+        <p14:section name="Close" id="{b1b33309-dc36-83bb-6f1d-7a55a2adaa1b}">
+          <p14:sldIdLst>
+            <p14:sldId id="263"/>
           </p14:sldIdLst>
         </p14:section>
       </p14:sectionLst>
@@ -928,7 +930,7 @@
 Every dish we read is stored once and Atlas embeds it automatically with Voyage AI.
 Recommendations run a hybrid search: $rankFusion combines full-text search, for exact words like prawn or gluten, with vector search, for meaning, and filters out dishes with your allergens. Voyage reranks the results.
 Then the LLM writes the answer only from the dishes Atlas returned, so it can't invent a menu.
-And it compounds: every menu one person reads makes the next search smarter. We already have more than 750 dishes.</a:t>
+And it compounds: every menu one person reads makes the next search smarter. We already have more than 630 dishes from real menus across 239 restaurants.</a:t>
             </a:r>
             <a:endParaRPr lang="en-US" dirty="0"/>
           </a:p>
@@ -1016,10 +1018,9 @@
           <a:p>
             <a:r>
               <a:rPr lang="en-US" dirty="0"/>
-              <a:t>[Armando, ~15 s]
-Food allergies are serious, so Mr Munch is honest: unknown never counts as safe. When the menu doesn't say, it tells you to ask the kitchen.
-It's private: we never store anyone's allergies. Your own Saint keeps them.
-And you stay in control: Saint always asks before it messages, books or pays.</a:t>
+              <a:t>[Marco, ~10 s, or leave it up for Q&amp;A]
+"And here's exactly how, in our code." Point at the grid: full-text search for exact allergen words, vector search with Atlas embedding every dish itself, $rankFusion to merge them, Voyage rerank, a 2dsphere index for 'near me', and upserts on a unique index so every menu read is stored once and shared.
+Source: lib/db/hybridSearch.ts, atlas/indexes/, lib/db/persist.ts, lib/services/mongodb.ts.</a:t>
             </a:r>
             <a:endParaRPr lang="en-US" dirty="0"/>
           </a:p>
@@ -1107,9 +1108,10 @@
           <a:p>
             <a:r>
               <a:rPr lang="en-US" dirty="0"/>
-              <a:t>[Marco, ~10 s]
-Mr Munch: find, read, check and book, so people like Armando and me can eat out without the fear.
-Thank you! The API is live at mrmunch.vercel.app and the code is on GitHub.</a:t>
+              <a:t>[Armando, ~15 s]
+Food allergies are serious, so Mr Munch is honest: unknown never counts as safe. When the menu doesn't say, it tells you to ask the kitchen.
+It's private: we never store anyone's allergies. Your own Saint keeps them.
+And you stay in control: Saint always asks before it messages, books or pays.</a:t>
             </a:r>
             <a:endParaRPr lang="en-US" dirty="0"/>
           </a:p>
@@ -1133,6 +1135,96 @@
             <a:fld id="{F7021451-1387-4CA6-816F-3879F97B5CBC}" type="slidenum">
               <a:rPr lang="en-US"/>
               <a:t>7</a:t>
+            </a:fld>
+            <a:endParaRPr lang="en-US"/>
+          </a:p>
+        </p:txBody>
+      </p:sp>
+    </p:spTree>
+    <p:extLst>
+      <p:ext uri="{BB962C8B-B14F-4D97-AF65-F5344CB8AC3E}">
+        <p14:creationId xmlns:p14="http://schemas.microsoft.com/office/powerpoint/2010/main" val="1024086991"/>
+      </p:ext>
+    </p:extLst>
+  </p:cSld>
+  <p:clrMapOvr>
+    <a:masterClrMapping/>
+  </p:clrMapOvr>
+</p:notes>
+</file>
+
+<file path=ppt/notesSlides/notesSlide8.xml><?xml version="1.0" encoding="utf-8"?>
+<p:notes xmlns:a="http://schemas.openxmlformats.org/drawingml/2006/main" xmlns:r="http://schemas.openxmlformats.org/officeDocument/2006/relationships" xmlns:p="http://schemas.openxmlformats.org/presentationml/2006/main">
+  <p:cSld>
+    <p:spTree>
+      <p:nvGrpSpPr>
+        <p:cNvPr id="1" name=""/>
+        <p:cNvGrpSpPr/>
+        <p:nvPr/>
+      </p:nvGrpSpPr>
+      <p:grpSpPr>
+        <a:xfrm>
+          <a:off x="0" y="0"/>
+          <a:ext cx="0" cy="0"/>
+          <a:chOff x="0" y="0"/>
+          <a:chExt cx="0" cy="0"/>
+        </a:xfrm>
+      </p:grpSpPr>
+      <p:sp>
+        <p:nvSpPr>
+          <p:cNvPr id="2" name="Slide Image Placeholder 1"/>
+          <p:cNvSpPr>
+            <a:spLocks noGrp="1" noRot="1" noChangeAspect="1"/>
+          </p:cNvSpPr>
+          <p:nvPr>
+            <p:ph type="sldImg"/>
+          </p:nvPr>
+        </p:nvSpPr>
+        <p:spPr/>
+      </p:sp>
+      <p:sp>
+        <p:nvSpPr>
+          <p:cNvPr id="3" name="Notes Placeholder 2"/>
+          <p:cNvSpPr>
+            <a:spLocks noGrp="1"/>
+          </p:cNvSpPr>
+          <p:nvPr>
+            <p:ph type="body" idx="1"/>
+          </p:nvPr>
+        </p:nvSpPr>
+        <p:spPr/>
+        <p:txBody>
+          <a:bodyPr/>
+          <a:lstStyle/>
+          <a:p>
+            <a:r>
+              <a:rPr lang="en-US" dirty="0"/>
+              <a:t>[Marco, ~10 s]
+Mr Munch: find, read, check and book, so people like Armando and me can eat out without the fear.
+Thank you! The API is live at mrmunch.vercel.app and the code is on GitHub.</a:t>
+            </a:r>
+            <a:endParaRPr lang="en-US" dirty="0"/>
+          </a:p>
+        </p:txBody>
+      </p:sp>
+      <p:sp>
+        <p:nvSpPr>
+          <p:cNvPr id="4" name="Slide Number Placeholder 3"/>
+          <p:cNvSpPr>
+            <a:spLocks noGrp="1"/>
+          </p:cNvSpPr>
+          <p:nvPr>
+            <p:ph type="sldNum" sz="quarter" idx="10"/>
+          </p:nvPr>
+        </p:nvSpPr>
+        <p:spPr/>
+        <p:txBody>
+          <a:bodyPr/>
+          <a:lstStyle/>
+          <a:p>
+            <a:fld id="{F7021451-1387-4CA6-816F-3879F97B5CBC}" type="slidenum">
+              <a:rPr lang="en-US"/>
+              <a:t>8</a:t>
             </a:fld>
             <a:endParaRPr lang="en-US"/>
           </a:p>
@@ -5748,7 +5840,7 @@
                 <a:ea typeface="Montserrat" pitchFamily="34" charset="-122"/>
                 <a:cs typeface="Montserrat" pitchFamily="34" charset="-120"/>
               </a:rPr>
-              <a:t>750+</a:t>
+              <a:t>630+</a:t>
             </a:r>
             <a:endParaRPr lang="en-US" sz="4800" dirty="0"/>
           </a:p>
@@ -5784,7 +5876,7 @@
                   <a:schemeClr val="tx1"/>
                 </a:solidFill>
               </a:rPr>
-              <a:t>dishes in Atlas, shared by every user</a:t>
+              <a:t>dishes from real menus, shared by every user</a:t>
             </a:r>
             <a:endParaRPr lang="en-US" sz="1400" dirty="0"/>
           </a:p>
@@ -5896,32 +5988,9 @@
           <a:chExt cx="0" cy="0"/>
         </a:xfrm>
       </p:grpSpPr>
-      <p:pic>
-        <p:nvPicPr>
-          <p:cNvPr id="2" name="Kitchen photo" descr="Restaurant kitchen with a chef at the pass">    </p:cNvPr>
-          <p:cNvPicPr>
-            <a:picLocks noChangeAspect="1"/>
-          </p:cNvPicPr>
-          <p:nvPr/>
-        </p:nvPicPr>
-        <p:blipFill>
-          <a:blip r:embed="rId1"/>
-          <a:srcRect l="0" r="0" t="0" b="0"/>
-          <a:stretch/>
-        </p:blipFill>
-        <p:spPr>
-          <a:xfrm>
-            <a:off x="0" y="0"/>
-            <a:ext cx="3474720" cy="5143500"/>
-          </a:xfrm>
-          <a:prstGeom prst="rect">
-            <a:avLst/>
-          </a:prstGeom>
-        </p:spPr>
-      </p:pic>
-      <p:sp>
-        <p:nvSpPr>
-          <p:cNvPr id="3" name="Text 0"/>
+      <p:sp>
+        <p:nvSpPr>
+          <p:cNvPr id="2" name="Text 0"/>
           <p:cNvSpPr/>
           <p:nvPr>
             <p:ph idx="100" type="title" hasCustomPrompt="1"/>
@@ -5929,8 +5998,8 @@
         </p:nvSpPr>
         <p:spPr>
           <a:xfrm>
-            <a:off x="3931920" y="365760"/>
-            <a:ext cx="4663440" cy="1005840"/>
+            <a:off x="548640" y="365760"/>
+            <a:ext cx="8046720" cy="731520"/>
           </a:xfrm>
           <a:prstGeom prst="rect">
             <a:avLst/>
@@ -5946,71 +6015,49 @@
               <a:buNone/>
             </a:pPr>
             <a:r>
-              <a:rPr lang="en-US" sz="3000" b="1" dirty="0">
+              <a:rPr lang="en-US" sz="3200" b="1" dirty="0">
                 <a:solidFill>
                   <a:schemeClr val="tx1"/>
                 </a:solidFill>
               </a:rPr>
-              <a:t>Honest, private and in your control</a:t>
-            </a:r>
-            <a:endParaRPr lang="en-US" sz="3000" dirty="0"/>
-          </a:p>
-        </p:txBody>
-      </p:sp>
-      <p:sp>
-        <p:nvSpPr>
-          <p:cNvPr id="4" name="Trust circle 1"/>
+              <a:t>MongoDB features in our code</a:t>
+            </a:r>
+            <a:endParaRPr lang="en-US" sz="3200" dirty="0"/>
+          </a:p>
+        </p:txBody>
+      </p:sp>
+      <p:sp>
+        <p:nvSpPr>
+          <p:cNvPr id="3" name="Code card 1"/>
           <p:cNvSpPr/>
           <p:nvPr/>
         </p:nvSpPr>
         <p:spPr>
           <a:xfrm>
-            <a:off x="3931920" y="1554480"/>
-            <a:ext cx="548640" cy="548640"/>
-          </a:xfrm>
-          <a:prstGeom prst="ellipse">
-            <a:avLst/>
+            <a:off x="548640" y="1188720"/>
+            <a:ext cx="2606040" cy="1691640"/>
+          </a:xfrm>
+          <a:prstGeom prst="roundRect">
+            <a:avLst>
+              <a:gd name="adj" fmla="val 5405"/>
+            </a:avLst>
           </a:prstGeom>
           <a:solidFill>
-            <a:schemeClr val="accent1"/>
+            <a:schemeClr val="tx2"/>
           </a:solidFill>
           <a:ln/>
         </p:spPr>
       </p:sp>
-      <p:pic>
-        <p:nvPicPr>
-          <p:cNvPr id="5" name="Trust icon 1" descr="Honest icon">    </p:cNvPr>
-          <p:cNvPicPr>
-            <a:picLocks noChangeAspect="1"/>
-          </p:cNvPicPr>
-          <p:nvPr/>
-        </p:nvPicPr>
-        <p:blipFill>
-          <a:blip r:embed="rId2"/>
-          <a:stretch>
-            <a:fillRect/>
-          </a:stretch>
-        </p:blipFill>
-        <p:spPr>
-          <a:xfrm>
-            <a:off x="4069080" y="1691640"/>
-            <a:ext cx="274320" cy="274320"/>
-          </a:xfrm>
-          <a:prstGeom prst="rect">
-            <a:avLst/>
-          </a:prstGeom>
-        </p:spPr>
-      </p:pic>
-      <p:sp>
-        <p:nvSpPr>
-          <p:cNvPr id="6" name="Trust title 1"/>
+      <p:sp>
+        <p:nvSpPr>
+          <p:cNvPr id="4" name="Code feature 1"/>
           <p:cNvSpPr txBox="1"/>
           <p:nvPr/>
         </p:nvSpPr>
         <p:spPr>
           <a:xfrm>
-            <a:off x="4663440" y="1508760"/>
-            <a:ext cx="3931920" cy="320040"/>
+            <a:off x="685800" y="1280160"/>
+            <a:ext cx="2377440" cy="256032"/>
           </a:xfrm>
           <a:prstGeom prst="rect">
             <a:avLst/>
@@ -6026,27 +6073,63 @@
               <a:buNone/>
             </a:pPr>
             <a:r>
-              <a:rPr lang="en-US" sz="1800" b="1" dirty="0">
-                <a:solidFill>
-                  <a:schemeClr val="tx1"/>
-                </a:solidFill>
-              </a:rPr>
-              <a:t>Honest</a:t>
-            </a:r>
-            <a:endParaRPr lang="en-US" sz="1800" dirty="0"/>
-          </a:p>
-        </p:txBody>
-      </p:sp>
-      <p:sp>
-        <p:nvSpPr>
-          <p:cNvPr id="7" name="Trust text 1"/>
+              <a:rPr lang="en-US" sz="1300" b="1" dirty="0">
+                <a:solidFill>
+                  <a:schemeClr val="bg1"/>
+                </a:solidFill>
+              </a:rPr>
+              <a:t>Atlas Search</a:t>
+            </a:r>
+            <a:endParaRPr lang="en-US" sz="1300" dirty="0"/>
+          </a:p>
+        </p:txBody>
+      </p:sp>
+      <p:sp>
+        <p:nvSpPr>
+          <p:cNvPr id="5" name="Code use 1"/>
           <p:cNvSpPr txBox="1"/>
           <p:nvPr/>
         </p:nvSpPr>
         <p:spPr>
           <a:xfrm>
-            <a:off x="4663440" y="1828800"/>
-            <a:ext cx="3931920" cy="685800"/>
+            <a:off x="685800" y="1517904"/>
+            <a:ext cx="2377440" cy="219456"/>
+          </a:xfrm>
+          <a:prstGeom prst="rect">
+            <a:avLst/>
+          </a:prstGeom>
+          <a:noFill/>
+          <a:ln/>
+        </p:spPr>
+        <p:txBody>
+          <a:bodyPr wrap="square" lIns="0" tIns="0" rIns="0" bIns="0" rtlCol="0" anchor="ctr"/>
+          <a:lstStyle/>
+          <a:p>
+            <a:pPr indent="0" marL="0">
+              <a:buNone/>
+            </a:pPr>
+            <a:r>
+              <a:rPr lang="en-US" sz="1050" dirty="0">
+                <a:solidFill>
+                  <a:schemeClr val="accent1"/>
+                </a:solidFill>
+              </a:rPr>
+              <a:t>Exact allergen words, typos</a:t>
+            </a:r>
+            <a:endParaRPr lang="en-US" sz="1050" dirty="0"/>
+          </a:p>
+        </p:txBody>
+      </p:sp>
+      <p:sp>
+        <p:nvSpPr>
+          <p:cNvPr id="6" name="Code snippet 1"/>
+          <p:cNvSpPr txBox="1"/>
+          <p:nvPr/>
+        </p:nvSpPr>
+        <p:spPr>
+          <a:xfrm>
+            <a:off x="685800" y="1792224"/>
+            <a:ext cx="2377440" cy="1024128"/>
           </a:xfrm>
           <a:prstGeom prst="rect">
             <a:avLst/>
@@ -6062,71 +6145,137 @@
               <a:buNone/>
             </a:pPr>
             <a:r>
-              <a:rPr lang="en-US" sz="1400" dirty="0">
-                <a:solidFill>
-                  <a:schemeClr val="accent3"/>
-                </a:solidFill>
-              </a:rPr>
-              <a:t>Unknown never counts as safe. Each place gets a confidence level, or a nudge to ask the kitchen.</a:t>
-            </a:r>
-            <a:endParaRPr lang="en-US" sz="1400" dirty="0"/>
-          </a:p>
-        </p:txBody>
-      </p:sp>
-      <p:sp>
-        <p:nvSpPr>
-          <p:cNvPr id="8" name="Trust circle 2"/>
+              <a:rPr lang="en-US" sz="900" dirty="0">
+                <a:solidFill>
+                  <a:schemeClr val="bg2"/>
+                </a:solidFill>
+                <a:latin typeface="Courier New" pitchFamily="34" charset="0"/>
+                <a:ea typeface="Courier New" pitchFamily="34" charset="-122"/>
+                <a:cs typeface="Courier New" pitchFamily="34" charset="-120"/>
+              </a:rPr>
+              <a:t>$search: { compound: {</a:t>
+            </a:r>
+            <a:endParaRPr lang="en-US" sz="900" dirty="0"/>
+          </a:p>
+          <a:p>
+            <a:pPr indent="0" marL="0">
+              <a:buNone/>
+            </a:pPr>
+            <a:r>
+              <a:rPr lang="en-US" sz="900" dirty="0">
+                <a:solidFill>
+                  <a:schemeClr val="bg2"/>
+                </a:solidFill>
+                <a:latin typeface="Courier New" pitchFamily="34" charset="0"/>
+                <a:ea typeface="Courier New" pitchFamily="34" charset="-122"/>
+                <a:cs typeface="Courier New" pitchFamily="34" charset="-120"/>
+              </a:rPr>
+              <a:t>  must: [{ text: { query,</a:t>
+            </a:r>
+            <a:endParaRPr lang="en-US" sz="900" dirty="0"/>
+          </a:p>
+          <a:p>
+            <a:pPr indent="0" marL="0">
+              <a:buNone/>
+            </a:pPr>
+            <a:r>
+              <a:rPr lang="en-US" sz="900" dirty="0">
+                <a:solidFill>
+                  <a:schemeClr val="bg2"/>
+                </a:solidFill>
+                <a:latin typeface="Courier New" pitchFamily="34" charset="0"/>
+                <a:ea typeface="Courier New" pitchFamily="34" charset="-122"/>
+                <a:cs typeface="Courier New" pitchFamily="34" charset="-120"/>
+              </a:rPr>
+              <a:t>    fuzzy: { maxEdits: 1 } } }],</a:t>
+            </a:r>
+            <a:endParaRPr lang="en-US" sz="900" dirty="0"/>
+          </a:p>
+          <a:p>
+            <a:pPr indent="0" marL="0">
+              <a:buNone/>
+            </a:pPr>
+            <a:r>
+              <a:rPr lang="en-US" sz="900" dirty="0">
+                <a:solidFill>
+                  <a:schemeClr val="bg2"/>
+                </a:solidFill>
+                <a:latin typeface="Courier New" pitchFamily="34" charset="0"/>
+                <a:ea typeface="Courier New" pitchFamily="34" charset="-122"/>
+                <a:cs typeface="Courier New" pitchFamily="34" charset="-120"/>
+              </a:rPr>
+              <a:t>  mustNot: [{ equals: {</a:t>
+            </a:r>
+            <a:endParaRPr lang="en-US" sz="900" dirty="0"/>
+          </a:p>
+          <a:p>
+            <a:pPr indent="0" marL="0">
+              <a:buNone/>
+            </a:pPr>
+            <a:r>
+              <a:rPr lang="en-US" sz="900" dirty="0">
+                <a:solidFill>
+                  <a:schemeClr val="bg2"/>
+                </a:solidFill>
+                <a:latin typeface="Courier New" pitchFamily="34" charset="0"/>
+                <a:ea typeface="Courier New" pitchFamily="34" charset="-122"/>
+                <a:cs typeface="Courier New" pitchFamily="34" charset="-120"/>
+              </a:rPr>
+              <a:t>    path: "allergensPresent",</a:t>
+            </a:r>
+            <a:endParaRPr lang="en-US" sz="900" dirty="0"/>
+          </a:p>
+          <a:p>
+            <a:pPr indent="0" marL="0">
+              <a:buNone/>
+            </a:pPr>
+            <a:r>
+              <a:rPr lang="en-US" sz="900" dirty="0">
+                <a:solidFill>
+                  <a:schemeClr val="bg2"/>
+                </a:solidFill>
+                <a:latin typeface="Courier New" pitchFamily="34" charset="0"/>
+                <a:ea typeface="Courier New" pitchFamily="34" charset="-122"/>
+                <a:cs typeface="Courier New" pitchFamily="34" charset="-120"/>
+              </a:rPr>
+              <a:t>    value: "crustaceans" } }] } }</a:t>
+            </a:r>
+            <a:endParaRPr lang="en-US" sz="900" dirty="0"/>
+          </a:p>
+        </p:txBody>
+      </p:sp>
+      <p:sp>
+        <p:nvSpPr>
+          <p:cNvPr id="7" name="Code card 2"/>
           <p:cNvSpPr/>
           <p:nvPr/>
         </p:nvSpPr>
         <p:spPr>
           <a:xfrm>
-            <a:off x="3931920" y="2651760"/>
-            <a:ext cx="548640" cy="548640"/>
-          </a:xfrm>
-          <a:prstGeom prst="ellipse">
-            <a:avLst/>
+            <a:off x="3268980" y="1188720"/>
+            <a:ext cx="2606040" cy="1691640"/>
+          </a:xfrm>
+          <a:prstGeom prst="roundRect">
+            <a:avLst>
+              <a:gd name="adj" fmla="val 5405"/>
+            </a:avLst>
           </a:prstGeom>
           <a:solidFill>
-            <a:schemeClr val="accent1"/>
+            <a:schemeClr val="tx2"/>
           </a:solidFill>
           <a:ln/>
         </p:spPr>
       </p:sp>
-      <p:pic>
-        <p:nvPicPr>
-          <p:cNvPr id="9" name="Trust icon 2" descr="Private icon">    </p:cNvPr>
-          <p:cNvPicPr>
-            <a:picLocks noChangeAspect="1"/>
-          </p:cNvPicPr>
-          <p:nvPr/>
-        </p:nvPicPr>
-        <p:blipFill>
-          <a:blip r:embed="rId3"/>
-          <a:stretch>
-            <a:fillRect/>
-          </a:stretch>
-        </p:blipFill>
-        <p:spPr>
-          <a:xfrm>
-            <a:off x="4069080" y="2788920"/>
-            <a:ext cx="274320" cy="274320"/>
-          </a:xfrm>
-          <a:prstGeom prst="rect">
-            <a:avLst/>
-          </a:prstGeom>
-        </p:spPr>
-      </p:pic>
-      <p:sp>
-        <p:nvSpPr>
-          <p:cNvPr id="10" name="Trust title 2"/>
+      <p:sp>
+        <p:nvSpPr>
+          <p:cNvPr id="8" name="Code feature 2"/>
           <p:cNvSpPr txBox="1"/>
           <p:nvPr/>
         </p:nvSpPr>
         <p:spPr>
           <a:xfrm>
-            <a:off x="4663440" y="2606040"/>
-            <a:ext cx="3931920" cy="320040"/>
+            <a:off x="3406140" y="1280160"/>
+            <a:ext cx="2377440" cy="256032"/>
           </a:xfrm>
           <a:prstGeom prst="rect">
             <a:avLst/>
@@ -6142,27 +6291,63 @@
               <a:buNone/>
             </a:pPr>
             <a:r>
-              <a:rPr lang="en-US" sz="1800" b="1" dirty="0">
-                <a:solidFill>
-                  <a:schemeClr val="tx1"/>
-                </a:solidFill>
-              </a:rPr>
-              <a:t>Private</a:t>
-            </a:r>
-            <a:endParaRPr lang="en-US" sz="1800" dirty="0"/>
-          </a:p>
-        </p:txBody>
-      </p:sp>
-      <p:sp>
-        <p:nvSpPr>
-          <p:cNvPr id="11" name="Trust text 2"/>
+              <a:rPr lang="en-US" sz="1300" b="1" dirty="0">
+                <a:solidFill>
+                  <a:schemeClr val="bg1"/>
+                </a:solidFill>
+              </a:rPr>
+              <a:t>Vector Search + Auto-embed</a:t>
+            </a:r>
+            <a:endParaRPr lang="en-US" sz="1300" dirty="0"/>
+          </a:p>
+        </p:txBody>
+      </p:sp>
+      <p:sp>
+        <p:nvSpPr>
+          <p:cNvPr id="9" name="Code use 2"/>
           <p:cNvSpPr txBox="1"/>
           <p:nvPr/>
         </p:nvSpPr>
         <p:spPr>
           <a:xfrm>
-            <a:off x="4663440" y="2926080"/>
-            <a:ext cx="3931920" cy="685800"/>
+            <a:off x="3406140" y="1517904"/>
+            <a:ext cx="2377440" cy="219456"/>
+          </a:xfrm>
+          <a:prstGeom prst="rect">
+            <a:avLst/>
+          </a:prstGeom>
+          <a:noFill/>
+          <a:ln/>
+        </p:spPr>
+        <p:txBody>
+          <a:bodyPr wrap="square" lIns="0" tIns="0" rIns="0" bIns="0" rtlCol="0" anchor="ctr"/>
+          <a:lstStyle/>
+          <a:p>
+            <a:pPr indent="0" marL="0">
+              <a:buNone/>
+            </a:pPr>
+            <a:r>
+              <a:rPr lang="en-US" sz="1050" dirty="0">
+                <a:solidFill>
+                  <a:schemeClr val="accent1"/>
+                </a:solidFill>
+              </a:rPr>
+              <a:t>Meaning; Atlas embeds every dish</a:t>
+            </a:r>
+            <a:endParaRPr lang="en-US" sz="1050" dirty="0"/>
+          </a:p>
+        </p:txBody>
+      </p:sp>
+      <p:sp>
+        <p:nvSpPr>
+          <p:cNvPr id="10" name="Code snippet 2"/>
+          <p:cNvSpPr txBox="1"/>
+          <p:nvPr/>
+        </p:nvSpPr>
+        <p:spPr>
+          <a:xfrm>
+            <a:off x="3406140" y="1792224"/>
+            <a:ext cx="2377440" cy="1024128"/>
           </a:xfrm>
           <a:prstGeom prst="rect">
             <a:avLst/>
@@ -6178,71 +6363,154 @@
               <a:buNone/>
             </a:pPr>
             <a:r>
-              <a:rPr lang="en-US" sz="1400" dirty="0">
-                <a:solidFill>
-                  <a:schemeClr val="accent3"/>
-                </a:solidFill>
-              </a:rPr>
-              <a:t>We never store anyone's allergies. Your own Saint keeps them and shares them per request.</a:t>
-            </a:r>
-            <a:endParaRPr lang="en-US" sz="1400" dirty="0"/>
-          </a:p>
-        </p:txBody>
-      </p:sp>
-      <p:sp>
-        <p:nvSpPr>
-          <p:cNvPr id="12" name="Trust circle 3"/>
+              <a:rPr lang="en-US" sz="900" dirty="0">
+                <a:solidFill>
+                  <a:schemeClr val="bg2"/>
+                </a:solidFill>
+                <a:latin typeface="Courier New" pitchFamily="34" charset="0"/>
+                <a:ea typeface="Courier New" pitchFamily="34" charset="-122"/>
+                <a:cs typeface="Courier New" pitchFamily="34" charset="-120"/>
+              </a:rPr>
+              <a:t>{ type: "autoEmbed",</a:t>
+            </a:r>
+            <a:endParaRPr lang="en-US" sz="900" dirty="0"/>
+          </a:p>
+          <a:p>
+            <a:pPr indent="0" marL="0">
+              <a:buNone/>
+            </a:pPr>
+            <a:r>
+              <a:rPr lang="en-US" sz="900" dirty="0">
+                <a:solidFill>
+                  <a:schemeClr val="bg2"/>
+                </a:solidFill>
+                <a:latin typeface="Courier New" pitchFamily="34" charset="0"/>
+                <a:ea typeface="Courier New" pitchFamily="34" charset="-122"/>
+                <a:cs typeface="Courier New" pitchFamily="34" charset="-120"/>
+              </a:rPr>
+              <a:t>  path: "searchText",</a:t>
+            </a:r>
+            <a:endParaRPr lang="en-US" sz="900" dirty="0"/>
+          </a:p>
+          <a:p>
+            <a:pPr indent="0" marL="0">
+              <a:buNone/>
+            </a:pPr>
+            <a:r>
+              <a:rPr lang="en-US" sz="900" dirty="0">
+                <a:solidFill>
+                  <a:schemeClr val="bg2"/>
+                </a:solidFill>
+                <a:latin typeface="Courier New" pitchFamily="34" charset="0"/>
+                <a:ea typeface="Courier New" pitchFamily="34" charset="-122"/>
+                <a:cs typeface="Courier New" pitchFamily="34" charset="-120"/>
+              </a:rPr>
+              <a:t>  model: "voyage-4" }</a:t>
+            </a:r>
+            <a:endParaRPr lang="en-US" sz="900" dirty="0"/>
+          </a:p>
+          <a:p>
+            <a:pPr indent="0" marL="0">
+              <a:buNone/>
+            </a:pPr>
+            <a:r>
+              <a:rPr lang="en-US" sz="900" dirty="0">
+                <a:solidFill>
+                  <a:schemeClr val="bg2"/>
+                </a:solidFill>
+                <a:latin typeface="Courier New" pitchFamily="34" charset="0"/>
+                <a:ea typeface="Courier New" pitchFamily="34" charset="-122"/>
+                <a:cs typeface="Courier New" pitchFamily="34" charset="-120"/>
+              </a:rPr>
+              <a:t>$vectorSearch: {</a:t>
+            </a:r>
+            <a:endParaRPr lang="en-US" sz="900" dirty="0"/>
+          </a:p>
+          <a:p>
+            <a:pPr indent="0" marL="0">
+              <a:buNone/>
+            </a:pPr>
+            <a:r>
+              <a:rPr lang="en-US" sz="900" dirty="0">
+                <a:solidFill>
+                  <a:schemeClr val="bg2"/>
+                </a:solidFill>
+                <a:latin typeface="Courier New" pitchFamily="34" charset="0"/>
+                <a:ea typeface="Courier New" pitchFamily="34" charset="-122"/>
+                <a:cs typeface="Courier New" pitchFamily="34" charset="-120"/>
+              </a:rPr>
+              <a:t>  query: { text: "vegan" },</a:t>
+            </a:r>
+            <a:endParaRPr lang="en-US" sz="900" dirty="0"/>
+          </a:p>
+          <a:p>
+            <a:pPr indent="0" marL="0">
+              <a:buNone/>
+            </a:pPr>
+            <a:r>
+              <a:rPr lang="en-US" sz="900" dirty="0">
+                <a:solidFill>
+                  <a:schemeClr val="bg2"/>
+                </a:solidFill>
+                <a:latin typeface="Courier New" pitchFamily="34" charset="0"/>
+                <a:ea typeface="Courier New" pitchFamily="34" charset="-122"/>
+                <a:cs typeface="Courier New" pitchFamily="34" charset="-120"/>
+              </a:rPr>
+              <a:t>  filter: { allergensPresent:</a:t>
+            </a:r>
+            <a:endParaRPr lang="en-US" sz="900" dirty="0"/>
+          </a:p>
+          <a:p>
+            <a:pPr indent="0" marL="0">
+              <a:buNone/>
+            </a:pPr>
+            <a:r>
+              <a:rPr lang="en-US" sz="900" dirty="0">
+                <a:solidFill>
+                  <a:schemeClr val="bg2"/>
+                </a:solidFill>
+                <a:latin typeface="Courier New" pitchFamily="34" charset="0"/>
+                <a:ea typeface="Courier New" pitchFamily="34" charset="-122"/>
+                <a:cs typeface="Courier New" pitchFamily="34" charset="-120"/>
+              </a:rPr>
+              <a:t>    { $nin: avoid } } }</a:t>
+            </a:r>
+            <a:endParaRPr lang="en-US" sz="900" dirty="0"/>
+          </a:p>
+        </p:txBody>
+      </p:sp>
+      <p:sp>
+        <p:nvSpPr>
+          <p:cNvPr id="11" name="Code card 3"/>
           <p:cNvSpPr/>
           <p:nvPr/>
         </p:nvSpPr>
         <p:spPr>
           <a:xfrm>
-            <a:off x="3931920" y="3749040"/>
-            <a:ext cx="548640" cy="548640"/>
-          </a:xfrm>
-          <a:prstGeom prst="ellipse">
-            <a:avLst/>
+            <a:off x="5989320" y="1188720"/>
+            <a:ext cx="2606040" cy="1691640"/>
+          </a:xfrm>
+          <a:prstGeom prst="roundRect">
+            <a:avLst>
+              <a:gd name="adj" fmla="val 5405"/>
+            </a:avLst>
           </a:prstGeom>
           <a:solidFill>
-            <a:schemeClr val="accent1"/>
+            <a:schemeClr val="tx2"/>
           </a:solidFill>
           <a:ln/>
         </p:spPr>
       </p:sp>
-      <p:pic>
-        <p:nvPicPr>
-          <p:cNvPr id="13" name="Trust icon 3" descr="In your control icon">    </p:cNvPr>
-          <p:cNvPicPr>
-            <a:picLocks noChangeAspect="1"/>
-          </p:cNvPicPr>
-          <p:nvPr/>
-        </p:nvPicPr>
-        <p:blipFill>
-          <a:blip r:embed="rId4"/>
-          <a:stretch>
-            <a:fillRect/>
-          </a:stretch>
-        </p:blipFill>
-        <p:spPr>
-          <a:xfrm>
-            <a:off x="4069080" y="3886200"/>
-            <a:ext cx="274320" cy="274320"/>
-          </a:xfrm>
-          <a:prstGeom prst="rect">
-            <a:avLst/>
-          </a:prstGeom>
-        </p:spPr>
-      </p:pic>
-      <p:sp>
-        <p:nvSpPr>
-          <p:cNvPr id="14" name="Trust title 3"/>
+      <p:sp>
+        <p:nvSpPr>
+          <p:cNvPr id="12" name="Code feature 3"/>
           <p:cNvSpPr txBox="1"/>
           <p:nvPr/>
         </p:nvSpPr>
         <p:spPr>
           <a:xfrm>
-            <a:off x="4663440" y="3703320"/>
-            <a:ext cx="3931920" cy="320040"/>
+            <a:off x="6126480" y="1280160"/>
+            <a:ext cx="2377440" cy="256032"/>
           </a:xfrm>
           <a:prstGeom prst="rect">
             <a:avLst/>
@@ -6258,27 +6526,63 @@
               <a:buNone/>
             </a:pPr>
             <a:r>
-              <a:rPr lang="en-US" sz="1800" b="1" dirty="0">
-                <a:solidFill>
-                  <a:schemeClr val="tx1"/>
-                </a:solidFill>
-              </a:rPr>
-              <a:t>In your control</a:t>
-            </a:r>
-            <a:endParaRPr lang="en-US" sz="1800" dirty="0"/>
-          </a:p>
-        </p:txBody>
-      </p:sp>
-      <p:sp>
-        <p:nvSpPr>
-          <p:cNvPr id="15" name="Trust text 3"/>
+              <a:rPr lang="en-US" sz="1300" b="1" dirty="0">
+                <a:solidFill>
+                  <a:schemeClr val="bg1"/>
+                </a:solidFill>
+              </a:rPr>
+              <a:t>Hybrid Search</a:t>
+            </a:r>
+            <a:endParaRPr lang="en-US" sz="1300" dirty="0"/>
+          </a:p>
+        </p:txBody>
+      </p:sp>
+      <p:sp>
+        <p:nvSpPr>
+          <p:cNvPr id="13" name="Code use 3"/>
           <p:cNvSpPr txBox="1"/>
           <p:nvPr/>
         </p:nvSpPr>
         <p:spPr>
           <a:xfrm>
-            <a:off x="4663440" y="4023360"/>
-            <a:ext cx="3931920" cy="685800"/>
+            <a:off x="6126480" y="1517904"/>
+            <a:ext cx="2377440" cy="219456"/>
+          </a:xfrm>
+          <a:prstGeom prst="rect">
+            <a:avLst/>
+          </a:prstGeom>
+          <a:noFill/>
+          <a:ln/>
+        </p:spPr>
+        <p:txBody>
+          <a:bodyPr wrap="square" lIns="0" tIns="0" rIns="0" bIns="0" rtlCol="0" anchor="ctr"/>
+          <a:lstStyle/>
+          <a:p>
+            <a:pPr indent="0" marL="0">
+              <a:buNone/>
+            </a:pPr>
+            <a:r>
+              <a:rPr lang="en-US" sz="1050" dirty="0">
+                <a:solidFill>
+                  <a:schemeClr val="accent1"/>
+                </a:solidFill>
+              </a:rPr>
+              <a:t>One ranked list from both</a:t>
+            </a:r>
+            <a:endParaRPr lang="en-US" sz="1050" dirty="0"/>
+          </a:p>
+        </p:txBody>
+      </p:sp>
+      <p:sp>
+        <p:nvSpPr>
+          <p:cNvPr id="14" name="Code snippet 3"/>
+          <p:cNvSpPr txBox="1"/>
+          <p:nvPr/>
+        </p:nvSpPr>
+        <p:spPr>
+          <a:xfrm>
+            <a:off x="6126480" y="1792224"/>
+            <a:ext cx="2377440" cy="1024128"/>
           </a:xfrm>
           <a:prstGeom prst="rect">
             <a:avLst/>
@@ -6294,14 +6598,757 @@
               <a:buNone/>
             </a:pPr>
             <a:r>
-              <a:rPr lang="en-US" sz="1400" dirty="0">
-                <a:solidFill>
-                  <a:schemeClr val="accent3"/>
-                </a:solidFill>
-              </a:rPr>
-              <a:t>Saint asks before it sends a message, books a table or pays a deposit.</a:t>
-            </a:r>
-            <a:endParaRPr lang="en-US" sz="1400" dirty="0"/>
+              <a:rPr lang="en-US" sz="900" dirty="0">
+                <a:solidFill>
+                  <a:schemeClr val="bg2"/>
+                </a:solidFill>
+                <a:latin typeface="Courier New" pitchFamily="34" charset="0"/>
+                <a:ea typeface="Courier New" pitchFamily="34" charset="-122"/>
+                <a:cs typeface="Courier New" pitchFamily="34" charset="-120"/>
+              </a:rPr>
+              <a:t>$rankFusion: {</a:t>
+            </a:r>
+            <a:endParaRPr lang="en-US" sz="900" dirty="0"/>
+          </a:p>
+          <a:p>
+            <a:pPr indent="0" marL="0">
+              <a:buNone/>
+            </a:pPr>
+            <a:r>
+              <a:rPr lang="en-US" sz="900" dirty="0">
+                <a:solidFill>
+                  <a:schemeClr val="bg2"/>
+                </a:solidFill>
+                <a:latin typeface="Courier New" pitchFamily="34" charset="0"/>
+                <a:ea typeface="Courier New" pitchFamily="34" charset="-122"/>
+                <a:cs typeface="Courier New" pitchFamily="34" charset="-120"/>
+              </a:rPr>
+              <a:t>  input: { pipelines: {</a:t>
+            </a:r>
+            <a:endParaRPr lang="en-US" sz="900" dirty="0"/>
+          </a:p>
+          <a:p>
+            <a:pPr indent="0" marL="0">
+              <a:buNone/>
+            </a:pPr>
+            <a:r>
+              <a:rPr lang="en-US" sz="900" dirty="0">
+                <a:solidFill>
+                  <a:schemeClr val="bg2"/>
+                </a:solidFill>
+                <a:latin typeface="Courier New" pitchFamily="34" charset="0"/>
+                <a:ea typeface="Courier New" pitchFamily="34" charset="-122"/>
+                <a:cs typeface="Courier New" pitchFamily="34" charset="-120"/>
+              </a:rPr>
+              <a:t>    vectorPipeline,</a:t>
+            </a:r>
+            <a:endParaRPr lang="en-US" sz="900" dirty="0"/>
+          </a:p>
+          <a:p>
+            <a:pPr indent="0" marL="0">
+              <a:buNone/>
+            </a:pPr>
+            <a:r>
+              <a:rPr lang="en-US" sz="900" dirty="0">
+                <a:solidFill>
+                  <a:schemeClr val="bg2"/>
+                </a:solidFill>
+                <a:latin typeface="Courier New" pitchFamily="34" charset="0"/>
+                <a:ea typeface="Courier New" pitchFamily="34" charset="-122"/>
+                <a:cs typeface="Courier New" pitchFamily="34" charset="-120"/>
+              </a:rPr>
+              <a:t>    fullTextPipeline } },</a:t>
+            </a:r>
+            <a:endParaRPr lang="en-US" sz="900" dirty="0"/>
+          </a:p>
+          <a:p>
+            <a:pPr indent="0" marL="0">
+              <a:buNone/>
+            </a:pPr>
+            <a:r>
+              <a:rPr lang="en-US" sz="900" dirty="0">
+                <a:solidFill>
+                  <a:schemeClr val="bg2"/>
+                </a:solidFill>
+                <a:latin typeface="Courier New" pitchFamily="34" charset="0"/>
+                <a:ea typeface="Courier New" pitchFamily="34" charset="-122"/>
+                <a:cs typeface="Courier New" pitchFamily="34" charset="-120"/>
+              </a:rPr>
+              <a:t>  combination: { weights: {</a:t>
+            </a:r>
+            <a:endParaRPr lang="en-US" sz="900" dirty="0"/>
+          </a:p>
+          <a:p>
+            <a:pPr indent="0" marL="0">
+              <a:buNone/>
+            </a:pPr>
+            <a:r>
+              <a:rPr lang="en-US" sz="900" dirty="0">
+                <a:solidFill>
+                  <a:schemeClr val="bg2"/>
+                </a:solidFill>
+                <a:latin typeface="Courier New" pitchFamily="34" charset="0"/>
+                <a:ea typeface="Courier New" pitchFamily="34" charset="-122"/>
+                <a:cs typeface="Courier New" pitchFamily="34" charset="-120"/>
+              </a:rPr>
+              <a:t>    vectorPipeline: 0.55,</a:t>
+            </a:r>
+            <a:endParaRPr lang="en-US" sz="900" dirty="0"/>
+          </a:p>
+          <a:p>
+            <a:pPr indent="0" marL="0">
+              <a:buNone/>
+            </a:pPr>
+            <a:r>
+              <a:rPr lang="en-US" sz="900" dirty="0">
+                <a:solidFill>
+                  <a:schemeClr val="bg2"/>
+                </a:solidFill>
+                <a:latin typeface="Courier New" pitchFamily="34" charset="0"/>
+                <a:ea typeface="Courier New" pitchFamily="34" charset="-122"/>
+                <a:cs typeface="Courier New" pitchFamily="34" charset="-120"/>
+              </a:rPr>
+              <a:t>    fullTextPipeline: 0.45 } } }</a:t>
+            </a:r>
+            <a:endParaRPr lang="en-US" sz="900" dirty="0"/>
+          </a:p>
+        </p:txBody>
+      </p:sp>
+      <p:sp>
+        <p:nvSpPr>
+          <p:cNvPr id="15" name="Code card 4"/>
+          <p:cNvSpPr/>
+          <p:nvPr/>
+        </p:nvSpPr>
+        <p:spPr>
+          <a:xfrm>
+            <a:off x="548640" y="2971800"/>
+            <a:ext cx="2606040" cy="1691640"/>
+          </a:xfrm>
+          <a:prstGeom prst="roundRect">
+            <a:avLst>
+              <a:gd name="adj" fmla="val 5405"/>
+            </a:avLst>
+          </a:prstGeom>
+          <a:solidFill>
+            <a:schemeClr val="tx2"/>
+          </a:solidFill>
+          <a:ln/>
+        </p:spPr>
+      </p:sp>
+      <p:sp>
+        <p:nvSpPr>
+          <p:cNvPr id="16" name="Code feature 4"/>
+          <p:cNvSpPr txBox="1"/>
+          <p:nvPr/>
+        </p:nvSpPr>
+        <p:spPr>
+          <a:xfrm>
+            <a:off x="685800" y="3063240"/>
+            <a:ext cx="2377440" cy="256032"/>
+          </a:xfrm>
+          <a:prstGeom prst="rect">
+            <a:avLst/>
+          </a:prstGeom>
+          <a:noFill/>
+          <a:ln/>
+        </p:spPr>
+        <p:txBody>
+          <a:bodyPr wrap="square" lIns="0" tIns="0" rIns="0" bIns="0" rtlCol="0" anchor="ctr"/>
+          <a:lstStyle/>
+          <a:p>
+            <a:pPr indent="0" marL="0">
+              <a:buNone/>
+            </a:pPr>
+            <a:r>
+              <a:rPr lang="en-US" sz="1300" b="1" dirty="0">
+                <a:solidFill>
+                  <a:schemeClr val="bg1"/>
+                </a:solidFill>
+              </a:rPr>
+              <a:t>Voyage AI rerank</a:t>
+            </a:r>
+            <a:endParaRPr lang="en-US" sz="1300" dirty="0"/>
+          </a:p>
+        </p:txBody>
+      </p:sp>
+      <p:sp>
+        <p:nvSpPr>
+          <p:cNvPr id="17" name="Code use 4"/>
+          <p:cNvSpPr txBox="1"/>
+          <p:nvPr/>
+        </p:nvSpPr>
+        <p:spPr>
+          <a:xfrm>
+            <a:off x="685800" y="3300984"/>
+            <a:ext cx="2377440" cy="219456"/>
+          </a:xfrm>
+          <a:prstGeom prst="rect">
+            <a:avLst/>
+          </a:prstGeom>
+          <a:noFill/>
+          <a:ln/>
+        </p:spPr>
+        <p:txBody>
+          <a:bodyPr wrap="square" lIns="0" tIns="0" rIns="0" bIns="0" rtlCol="0" anchor="ctr"/>
+          <a:lstStyle/>
+          <a:p>
+            <a:pPr indent="0" marL="0">
+              <a:buNone/>
+            </a:pPr>
+            <a:r>
+              <a:rPr lang="en-US" sz="1050" dirty="0">
+                <a:solidFill>
+                  <a:schemeClr val="accent1"/>
+                </a:solidFill>
+              </a:rPr>
+              <a:t>Best dishes first, then the LLM</a:t>
+            </a:r>
+            <a:endParaRPr lang="en-US" sz="1050" dirty="0"/>
+          </a:p>
+        </p:txBody>
+      </p:sp>
+      <p:sp>
+        <p:nvSpPr>
+          <p:cNvPr id="18" name="Code snippet 4"/>
+          <p:cNvSpPr txBox="1"/>
+          <p:nvPr/>
+        </p:nvSpPr>
+        <p:spPr>
+          <a:xfrm>
+            <a:off x="685800" y="3575304"/>
+            <a:ext cx="2377440" cy="1024128"/>
+          </a:xfrm>
+          <a:prstGeom prst="rect">
+            <a:avLst/>
+          </a:prstGeom>
+          <a:noFill/>
+          <a:ln/>
+        </p:spPr>
+        <p:txBody>
+          <a:bodyPr wrap="square" lIns="0" tIns="0" rIns="0" bIns="0" rtlCol="0" anchor="t"/>
+          <a:lstStyle/>
+          <a:p>
+            <a:pPr indent="0" marL="0">
+              <a:buNone/>
+            </a:pPr>
+            <a:r>
+              <a:rPr lang="en-US" sz="900" dirty="0">
+                <a:solidFill>
+                  <a:schemeClr val="bg2"/>
+                </a:solidFill>
+                <a:latin typeface="Courier New" pitchFamily="34" charset="0"/>
+                <a:ea typeface="Courier New" pitchFamily="34" charset="-122"/>
+                <a:cs typeface="Courier New" pitchFamily="34" charset="-120"/>
+              </a:rPr>
+              <a:t>{ $rerank: {</a:t>
+            </a:r>
+            <a:endParaRPr lang="en-US" sz="900" dirty="0"/>
+          </a:p>
+          <a:p>
+            <a:pPr indent="0" marL="0">
+              <a:buNone/>
+            </a:pPr>
+            <a:r>
+              <a:rPr lang="en-US" sz="900" dirty="0">
+                <a:solidFill>
+                  <a:schemeClr val="bg2"/>
+                </a:solidFill>
+                <a:latin typeface="Courier New" pitchFamily="34" charset="0"/>
+                <a:ea typeface="Courier New" pitchFamily="34" charset="-122"/>
+                <a:cs typeface="Courier New" pitchFamily="34" charset="-120"/>
+              </a:rPr>
+              <a:t>    model: "rerank-2.5",</a:t>
+            </a:r>
+            <a:endParaRPr lang="en-US" sz="900" dirty="0"/>
+          </a:p>
+          <a:p>
+            <a:pPr indent="0" marL="0">
+              <a:buNone/>
+            </a:pPr>
+            <a:r>
+              <a:rPr lang="en-US" sz="900" dirty="0">
+                <a:solidFill>
+                  <a:schemeClr val="bg2"/>
+                </a:solidFill>
+                <a:latin typeface="Courier New" pitchFamily="34" charset="0"/>
+                <a:ea typeface="Courier New" pitchFamily="34" charset="-122"/>
+                <a:cs typeface="Courier New" pitchFamily="34" charset="-120"/>
+              </a:rPr>
+              <a:t>    path: "searchText",</a:t>
+            </a:r>
+            <a:endParaRPr lang="en-US" sz="900" dirty="0"/>
+          </a:p>
+          <a:p>
+            <a:pPr indent="0" marL="0">
+              <a:buNone/>
+            </a:pPr>
+            <a:r>
+              <a:rPr lang="en-US" sz="900" dirty="0">
+                <a:solidFill>
+                  <a:schemeClr val="bg2"/>
+                </a:solidFill>
+                <a:latin typeface="Courier New" pitchFamily="34" charset="0"/>
+                <a:ea typeface="Courier New" pitchFamily="34" charset="-122"/>
+                <a:cs typeface="Courier New" pitchFamily="34" charset="-120"/>
+              </a:rPr>
+              <a:t>    numDocsToRerank: 40 } }</a:t>
+            </a:r>
+            <a:endParaRPr lang="en-US" sz="900" dirty="0"/>
+          </a:p>
+          <a:p>
+            <a:pPr indent="0" marL="0">
+              <a:buNone/>
+            </a:pPr>
+            <a:endParaRPr lang="en-US" sz="900" dirty="0"/>
+          </a:p>
+          <a:p>
+            <a:pPr indent="0" marL="0">
+              <a:buNone/>
+            </a:pPr>
+            <a:r>
+              <a:rPr lang="en-US" sz="900" dirty="0">
+                <a:solidFill>
+                  <a:schemeClr val="bg2"/>
+                </a:solidFill>
+                <a:latin typeface="Courier New" pitchFamily="34" charset="0"/>
+                <a:ea typeface="Courier New" pitchFamily="34" charset="-122"/>
+                <a:cs typeface="Courier New" pitchFamily="34" charset="-120"/>
+              </a:rPr>
+              <a:t>// Voyage API on MongoDB 8.0</a:t>
+            </a:r>
+            <a:endParaRPr lang="en-US" sz="900" dirty="0"/>
+          </a:p>
+        </p:txBody>
+      </p:sp>
+      <p:sp>
+        <p:nvSpPr>
+          <p:cNvPr id="19" name="Code card 5"/>
+          <p:cNvSpPr/>
+          <p:nvPr/>
+        </p:nvSpPr>
+        <p:spPr>
+          <a:xfrm>
+            <a:off x="3268980" y="2971800"/>
+            <a:ext cx="2606040" cy="1691640"/>
+          </a:xfrm>
+          <a:prstGeom prst="roundRect">
+            <a:avLst>
+              <a:gd name="adj" fmla="val 5405"/>
+            </a:avLst>
+          </a:prstGeom>
+          <a:solidFill>
+            <a:schemeClr val="tx2"/>
+          </a:solidFill>
+          <a:ln/>
+        </p:spPr>
+      </p:sp>
+      <p:sp>
+        <p:nvSpPr>
+          <p:cNvPr id="20" name="Code feature 5"/>
+          <p:cNvSpPr txBox="1"/>
+          <p:nvPr/>
+        </p:nvSpPr>
+        <p:spPr>
+          <a:xfrm>
+            <a:off x="3406140" y="3063240"/>
+            <a:ext cx="2377440" cy="256032"/>
+          </a:xfrm>
+          <a:prstGeom prst="rect">
+            <a:avLst/>
+          </a:prstGeom>
+          <a:noFill/>
+          <a:ln/>
+        </p:spPr>
+        <p:txBody>
+          <a:bodyPr wrap="square" lIns="0" tIns="0" rIns="0" bIns="0" rtlCol="0" anchor="ctr"/>
+          <a:lstStyle/>
+          <a:p>
+            <a:pPr indent="0" marL="0">
+              <a:buNone/>
+            </a:pPr>
+            <a:r>
+              <a:rPr lang="en-US" sz="1300" b="1" dirty="0">
+                <a:solidFill>
+                  <a:schemeClr val="bg1"/>
+                </a:solidFill>
+              </a:rPr>
+              <a:t>Geospatial</a:t>
+            </a:r>
+            <a:endParaRPr lang="en-US" sz="1300" dirty="0"/>
+          </a:p>
+        </p:txBody>
+      </p:sp>
+      <p:sp>
+        <p:nvSpPr>
+          <p:cNvPr id="21" name="Code use 5"/>
+          <p:cNvSpPr txBox="1"/>
+          <p:nvPr/>
+        </p:nvSpPr>
+        <p:spPr>
+          <a:xfrm>
+            <a:off x="3406140" y="3300984"/>
+            <a:ext cx="2377440" cy="219456"/>
+          </a:xfrm>
+          <a:prstGeom prst="rect">
+            <a:avLst/>
+          </a:prstGeom>
+          <a:noFill/>
+          <a:ln/>
+        </p:spPr>
+        <p:txBody>
+          <a:bodyPr wrap="square" lIns="0" tIns="0" rIns="0" bIns="0" rtlCol="0" anchor="ctr"/>
+          <a:lstStyle/>
+          <a:p>
+            <a:pPr indent="0" marL="0">
+              <a:buNone/>
+            </a:pPr>
+            <a:r>
+              <a:rPr lang="en-US" sz="1050" dirty="0">
+                <a:solidFill>
+                  <a:schemeClr val="accent1"/>
+                </a:solidFill>
+              </a:rPr>
+              <a:t>Restaurants and dishes near you</a:t>
+            </a:r>
+            <a:endParaRPr lang="en-US" sz="1050" dirty="0"/>
+          </a:p>
+        </p:txBody>
+      </p:sp>
+      <p:sp>
+        <p:nvSpPr>
+          <p:cNvPr id="22" name="Code snippet 5"/>
+          <p:cNvSpPr txBox="1"/>
+          <p:nvPr/>
+        </p:nvSpPr>
+        <p:spPr>
+          <a:xfrm>
+            <a:off x="3406140" y="3575304"/>
+            <a:ext cx="2377440" cy="1024128"/>
+          </a:xfrm>
+          <a:prstGeom prst="rect">
+            <a:avLst/>
+          </a:prstGeom>
+          <a:noFill/>
+          <a:ln/>
+        </p:spPr>
+        <p:txBody>
+          <a:bodyPr wrap="square" lIns="0" tIns="0" rIns="0" bIns="0" rtlCol="0" anchor="t"/>
+          <a:lstStyle/>
+          <a:p>
+            <a:pPr indent="0" marL="0">
+              <a:buNone/>
+            </a:pPr>
+            <a:r>
+              <a:rPr lang="en-US" sz="900" dirty="0">
+                <a:solidFill>
+                  <a:schemeClr val="bg2"/>
+                </a:solidFill>
+                <a:latin typeface="Courier New" pitchFamily="34" charset="0"/>
+                <a:ea typeface="Courier New" pitchFamily="34" charset="-122"/>
+                <a:cs typeface="Courier New" pitchFamily="34" charset="-120"/>
+              </a:rPr>
+              <a:t>{ location: "2dsphere" }</a:t>
+            </a:r>
+            <a:endParaRPr lang="en-US" sz="900" dirty="0"/>
+          </a:p>
+          <a:p>
+            <a:pPr indent="0" marL="0">
+              <a:buNone/>
+            </a:pPr>
+            <a:endParaRPr lang="en-US" sz="900" dirty="0"/>
+          </a:p>
+          <a:p>
+            <a:pPr indent="0" marL="0">
+              <a:buNone/>
+            </a:pPr>
+            <a:r>
+              <a:rPr lang="en-US" sz="900" dirty="0">
+                <a:solidFill>
+                  <a:schemeClr val="bg2"/>
+                </a:solidFill>
+                <a:latin typeface="Courier New" pitchFamily="34" charset="0"/>
+                <a:ea typeface="Courier New" pitchFamily="34" charset="-122"/>
+                <a:cs typeface="Courier New" pitchFamily="34" charset="-120"/>
+              </a:rPr>
+              <a:t>location: { $near: {</a:t>
+            </a:r>
+            <a:endParaRPr lang="en-US" sz="900" dirty="0"/>
+          </a:p>
+          <a:p>
+            <a:pPr indent="0" marL="0">
+              <a:buNone/>
+            </a:pPr>
+            <a:r>
+              <a:rPr lang="en-US" sz="900" dirty="0">
+                <a:solidFill>
+                  <a:schemeClr val="bg2"/>
+                </a:solidFill>
+                <a:latin typeface="Courier New" pitchFamily="34" charset="0"/>
+                <a:ea typeface="Courier New" pitchFamily="34" charset="-122"/>
+                <a:cs typeface="Courier New" pitchFamily="34" charset="-120"/>
+              </a:rPr>
+              <a:t>  $geometry: { type: "Point",</a:t>
+            </a:r>
+            <a:endParaRPr lang="en-US" sz="900" dirty="0"/>
+          </a:p>
+          <a:p>
+            <a:pPr indent="0" marL="0">
+              <a:buNone/>
+            </a:pPr>
+            <a:r>
+              <a:rPr lang="en-US" sz="900" dirty="0">
+                <a:solidFill>
+                  <a:schemeClr val="bg2"/>
+                </a:solidFill>
+                <a:latin typeface="Courier New" pitchFamily="34" charset="0"/>
+                <a:ea typeface="Courier New" pitchFamily="34" charset="-122"/>
+                <a:cs typeface="Courier New" pitchFamily="34" charset="-120"/>
+              </a:rPr>
+              <a:t>    coordinates: [lng, lat] },</a:t>
+            </a:r>
+            <a:endParaRPr lang="en-US" sz="900" dirty="0"/>
+          </a:p>
+          <a:p>
+            <a:pPr indent="0" marL="0">
+              <a:buNone/>
+            </a:pPr>
+            <a:r>
+              <a:rPr lang="en-US" sz="900" dirty="0">
+                <a:solidFill>
+                  <a:schemeClr val="bg2"/>
+                </a:solidFill>
+                <a:latin typeface="Courier New" pitchFamily="34" charset="0"/>
+                <a:ea typeface="Courier New" pitchFamily="34" charset="-122"/>
+                <a:cs typeface="Courier New" pitchFamily="34" charset="-120"/>
+              </a:rPr>
+              <a:t>  $maxDistance: 2000 } }</a:t>
+            </a:r>
+            <a:endParaRPr lang="en-US" sz="900" dirty="0"/>
+          </a:p>
+        </p:txBody>
+      </p:sp>
+      <p:sp>
+        <p:nvSpPr>
+          <p:cNvPr id="23" name="Code card 6"/>
+          <p:cNvSpPr/>
+          <p:nvPr/>
+        </p:nvSpPr>
+        <p:spPr>
+          <a:xfrm>
+            <a:off x="5989320" y="2971800"/>
+            <a:ext cx="2606040" cy="1691640"/>
+          </a:xfrm>
+          <a:prstGeom prst="roundRect">
+            <a:avLst>
+              <a:gd name="adj" fmla="val 5405"/>
+            </a:avLst>
+          </a:prstGeom>
+          <a:solidFill>
+            <a:schemeClr val="tx2"/>
+          </a:solidFill>
+          <a:ln/>
+        </p:spPr>
+      </p:sp>
+      <p:sp>
+        <p:nvSpPr>
+          <p:cNvPr id="24" name="Code feature 6"/>
+          <p:cNvSpPr txBox="1"/>
+          <p:nvPr/>
+        </p:nvSpPr>
+        <p:spPr>
+          <a:xfrm>
+            <a:off x="6126480" y="3063240"/>
+            <a:ext cx="2377440" cy="256032"/>
+          </a:xfrm>
+          <a:prstGeom prst="rect">
+            <a:avLst/>
+          </a:prstGeom>
+          <a:noFill/>
+          <a:ln/>
+        </p:spPr>
+        <p:txBody>
+          <a:bodyPr wrap="square" lIns="0" tIns="0" rIns="0" bIns="0" rtlCol="0" anchor="ctr"/>
+          <a:lstStyle/>
+          <a:p>
+            <a:pPr indent="0" marL="0">
+              <a:buNone/>
+            </a:pPr>
+            <a:r>
+              <a:rPr lang="en-US" sz="1300" b="1" dirty="0">
+                <a:solidFill>
+                  <a:schemeClr val="bg1"/>
+                </a:solidFill>
+              </a:rPr>
+              <a:t>Upserts + unique index</a:t>
+            </a:r>
+            <a:endParaRPr lang="en-US" sz="1300" dirty="0"/>
+          </a:p>
+        </p:txBody>
+      </p:sp>
+      <p:sp>
+        <p:nvSpPr>
+          <p:cNvPr id="25" name="Code use 6"/>
+          <p:cNvSpPr txBox="1"/>
+          <p:nvPr/>
+        </p:nvSpPr>
+        <p:spPr>
+          <a:xfrm>
+            <a:off x="6126480" y="3300984"/>
+            <a:ext cx="2377440" cy="219456"/>
+          </a:xfrm>
+          <a:prstGeom prst="rect">
+            <a:avLst/>
+          </a:prstGeom>
+          <a:noFill/>
+          <a:ln/>
+        </p:spPr>
+        <p:txBody>
+          <a:bodyPr wrap="square" lIns="0" tIns="0" rIns="0" bIns="0" rtlCol="0" anchor="ctr"/>
+          <a:lstStyle/>
+          <a:p>
+            <a:pPr indent="0" marL="0">
+              <a:buNone/>
+            </a:pPr>
+            <a:r>
+              <a:rPr lang="en-US" sz="1050" dirty="0">
+                <a:solidFill>
+                  <a:schemeClr val="accent1"/>
+                </a:solidFill>
+              </a:rPr>
+              <a:t>Shared knowledge, no duplicates</a:t>
+            </a:r>
+            <a:endParaRPr lang="en-US" sz="1050" dirty="0"/>
+          </a:p>
+        </p:txBody>
+      </p:sp>
+      <p:sp>
+        <p:nvSpPr>
+          <p:cNvPr id="26" name="Code snippet 6"/>
+          <p:cNvSpPr txBox="1"/>
+          <p:nvPr/>
+        </p:nvSpPr>
+        <p:spPr>
+          <a:xfrm>
+            <a:off x="6126480" y="3575304"/>
+            <a:ext cx="2377440" cy="1024128"/>
+          </a:xfrm>
+          <a:prstGeom prst="rect">
+            <a:avLst/>
+          </a:prstGeom>
+          <a:noFill/>
+          <a:ln/>
+        </p:spPr>
+        <p:txBody>
+          <a:bodyPr wrap="square" lIns="0" tIns="0" rIns="0" bIns="0" rtlCol="0" anchor="t"/>
+          <a:lstStyle/>
+          <a:p>
+            <a:pPr indent="0" marL="0">
+              <a:buNone/>
+            </a:pPr>
+            <a:r>
+              <a:rPr lang="en-US" sz="900" dirty="0">
+                <a:solidFill>
+                  <a:schemeClr val="bg2"/>
+                </a:solidFill>
+                <a:latin typeface="Courier New" pitchFamily="34" charset="0"/>
+                <a:ea typeface="Courier New" pitchFamily="34" charset="-122"/>
+                <a:cs typeface="Courier New" pitchFamily="34" charset="-120"/>
+              </a:rPr>
+              <a:t>createIndex(</a:t>
+            </a:r>
+            <a:endParaRPr lang="en-US" sz="900" dirty="0"/>
+          </a:p>
+          <a:p>
+            <a:pPr indent="0" marL="0">
+              <a:buNone/>
+            </a:pPr>
+            <a:r>
+              <a:rPr lang="en-US" sz="900" dirty="0">
+                <a:solidFill>
+                  <a:schemeClr val="bg2"/>
+                </a:solidFill>
+                <a:latin typeface="Courier New" pitchFamily="34" charset="0"/>
+                <a:ea typeface="Courier New" pitchFamily="34" charset="-122"/>
+                <a:cs typeface="Courier New" pitchFamily="34" charset="-120"/>
+              </a:rPr>
+              <a:t>  { restaurantPlaceId: 1,</a:t>
+            </a:r>
+            <a:endParaRPr lang="en-US" sz="900" dirty="0"/>
+          </a:p>
+          <a:p>
+            <a:pPr indent="0" marL="0">
+              <a:buNone/>
+            </a:pPr>
+            <a:r>
+              <a:rPr lang="en-US" sz="900" dirty="0">
+                <a:solidFill>
+                  <a:schemeClr val="bg2"/>
+                </a:solidFill>
+                <a:latin typeface="Courier New" pitchFamily="34" charset="0"/>
+                <a:ea typeface="Courier New" pitchFamily="34" charset="-122"/>
+                <a:cs typeface="Courier New" pitchFamily="34" charset="-120"/>
+              </a:rPr>
+              <a:t>    name: 1 },</a:t>
+            </a:r>
+            <a:endParaRPr lang="en-US" sz="900" dirty="0"/>
+          </a:p>
+          <a:p>
+            <a:pPr indent="0" marL="0">
+              <a:buNone/>
+            </a:pPr>
+            <a:r>
+              <a:rPr lang="en-US" sz="900" dirty="0">
+                <a:solidFill>
+                  <a:schemeClr val="bg2"/>
+                </a:solidFill>
+                <a:latin typeface="Courier New" pitchFamily="34" charset="0"/>
+                <a:ea typeface="Courier New" pitchFamily="34" charset="-122"/>
+                <a:cs typeface="Courier New" pitchFamily="34" charset="-120"/>
+              </a:rPr>
+              <a:t>  { unique: true })</a:t>
+            </a:r>
+            <a:endParaRPr lang="en-US" sz="900" dirty="0"/>
+          </a:p>
+          <a:p>
+            <a:pPr indent="0" marL="0">
+              <a:buNone/>
+            </a:pPr>
+            <a:endParaRPr lang="en-US" sz="900" dirty="0"/>
+          </a:p>
+          <a:p>
+            <a:pPr indent="0" marL="0">
+              <a:buNone/>
+            </a:pPr>
+            <a:r>
+              <a:rPr lang="en-US" sz="900" dirty="0">
+                <a:solidFill>
+                  <a:schemeClr val="bg2"/>
+                </a:solidFill>
+                <a:latin typeface="Courier New" pitchFamily="34" charset="0"/>
+                <a:ea typeface="Courier New" pitchFamily="34" charset="-122"/>
+                <a:cs typeface="Courier New" pitchFamily="34" charset="-120"/>
+              </a:rPr>
+              <a:t>updateOne(key, { $set: dish },</a:t>
+            </a:r>
+            <a:endParaRPr lang="en-US" sz="900" dirty="0"/>
+          </a:p>
+          <a:p>
+            <a:pPr indent="0" marL="0">
+              <a:buNone/>
+            </a:pPr>
+            <a:r>
+              <a:rPr lang="en-US" sz="900" dirty="0">
+                <a:solidFill>
+                  <a:schemeClr val="bg2"/>
+                </a:solidFill>
+                <a:latin typeface="Courier New" pitchFamily="34" charset="0"/>
+                <a:ea typeface="Courier New" pitchFamily="34" charset="-122"/>
+                <a:cs typeface="Courier New" pitchFamily="34" charset="-120"/>
+              </a:rPr>
+              <a:t>  { upsert: true })</a:t>
+            </a:r>
+            <a:endParaRPr lang="en-US" sz="900" dirty="0"/>
           </a:p>
         </p:txBody>
       </p:sp>
@@ -6361,6 +7408,485 @@
 <file path=ppt/slides/slide7.xml><?xml version="1.0" encoding="utf-8"?>
 <p:sld xmlns:a="http://schemas.openxmlformats.org/drawingml/2006/main" xmlns:r="http://schemas.openxmlformats.org/officeDocument/2006/relationships" xmlns:p="http://schemas.openxmlformats.org/presentationml/2006/main">
   <p:cSld name="Slide 7">
+    <p:spTree>
+      <p:nvGrpSpPr>
+        <p:cNvPr id="1" name=""/>
+        <p:cNvGrpSpPr/>
+        <p:nvPr/>
+      </p:nvGrpSpPr>
+      <p:grpSpPr>
+        <a:xfrm>
+          <a:off x="0" y="0"/>
+          <a:ext cx="0" cy="0"/>
+          <a:chOff x="0" y="0"/>
+          <a:chExt cx="0" cy="0"/>
+        </a:xfrm>
+      </p:grpSpPr>
+      <p:pic>
+        <p:nvPicPr>
+          <p:cNvPr id="2" name="Kitchen photo" descr="Restaurant kitchen with a chef at the pass">    </p:cNvPr>
+          <p:cNvPicPr>
+            <a:picLocks noChangeAspect="1"/>
+          </p:cNvPicPr>
+          <p:nvPr/>
+        </p:nvPicPr>
+        <p:blipFill>
+          <a:blip r:embed="rId1"/>
+          <a:srcRect l="0" r="0" t="0" b="0"/>
+          <a:stretch/>
+        </p:blipFill>
+        <p:spPr>
+          <a:xfrm>
+            <a:off x="0" y="0"/>
+            <a:ext cx="3474720" cy="5143500"/>
+          </a:xfrm>
+          <a:prstGeom prst="rect">
+            <a:avLst/>
+          </a:prstGeom>
+        </p:spPr>
+      </p:pic>
+      <p:sp>
+        <p:nvSpPr>
+          <p:cNvPr id="3" name="Text 0"/>
+          <p:cNvSpPr/>
+          <p:nvPr>
+            <p:ph idx="100" type="title" hasCustomPrompt="1"/>
+          </p:nvPr>
+        </p:nvSpPr>
+        <p:spPr>
+          <a:xfrm>
+            <a:off x="3931920" y="365760"/>
+            <a:ext cx="4663440" cy="1005840"/>
+          </a:xfrm>
+          <a:prstGeom prst="rect">
+            <a:avLst/>
+          </a:prstGeom>
+          <a:noFill/>
+          <a:ln/>
+        </p:spPr>
+        <p:txBody>
+          <a:bodyPr wrap="square" lIns="0" tIns="0" rIns="0" bIns="0" rtlCol="0" anchor="ctr"/>
+          <a:lstStyle/>
+          <a:p>
+            <a:pPr algn="l" indent="0" marL="0">
+              <a:buNone/>
+            </a:pPr>
+            <a:r>
+              <a:rPr lang="en-US" sz="3000" b="1" dirty="0">
+                <a:solidFill>
+                  <a:schemeClr val="tx1"/>
+                </a:solidFill>
+              </a:rPr>
+              <a:t>Honest, private and in your control</a:t>
+            </a:r>
+            <a:endParaRPr lang="en-US" sz="3000" dirty="0"/>
+          </a:p>
+        </p:txBody>
+      </p:sp>
+      <p:sp>
+        <p:nvSpPr>
+          <p:cNvPr id="4" name="Trust circle 1"/>
+          <p:cNvSpPr/>
+          <p:nvPr/>
+        </p:nvSpPr>
+        <p:spPr>
+          <a:xfrm>
+            <a:off x="3931920" y="1554480"/>
+            <a:ext cx="548640" cy="548640"/>
+          </a:xfrm>
+          <a:prstGeom prst="ellipse">
+            <a:avLst/>
+          </a:prstGeom>
+          <a:solidFill>
+            <a:schemeClr val="accent1"/>
+          </a:solidFill>
+          <a:ln/>
+        </p:spPr>
+      </p:sp>
+      <p:pic>
+        <p:nvPicPr>
+          <p:cNvPr id="5" name="Trust icon 1" descr="Honest icon">    </p:cNvPr>
+          <p:cNvPicPr>
+            <a:picLocks noChangeAspect="1"/>
+          </p:cNvPicPr>
+          <p:nvPr/>
+        </p:nvPicPr>
+        <p:blipFill>
+          <a:blip r:embed="rId2"/>
+          <a:stretch>
+            <a:fillRect/>
+          </a:stretch>
+        </p:blipFill>
+        <p:spPr>
+          <a:xfrm>
+            <a:off x="4069080" y="1691640"/>
+            <a:ext cx="274320" cy="274320"/>
+          </a:xfrm>
+          <a:prstGeom prst="rect">
+            <a:avLst/>
+          </a:prstGeom>
+        </p:spPr>
+      </p:pic>
+      <p:sp>
+        <p:nvSpPr>
+          <p:cNvPr id="6" name="Trust title 1"/>
+          <p:cNvSpPr txBox="1"/>
+          <p:nvPr/>
+        </p:nvSpPr>
+        <p:spPr>
+          <a:xfrm>
+            <a:off x="4663440" y="1508760"/>
+            <a:ext cx="3931920" cy="320040"/>
+          </a:xfrm>
+          <a:prstGeom prst="rect">
+            <a:avLst/>
+          </a:prstGeom>
+          <a:noFill/>
+          <a:ln/>
+        </p:spPr>
+        <p:txBody>
+          <a:bodyPr wrap="square" lIns="0" tIns="0" rIns="0" bIns="0" rtlCol="0" anchor="ctr"/>
+          <a:lstStyle/>
+          <a:p>
+            <a:pPr indent="0" marL="0">
+              <a:buNone/>
+            </a:pPr>
+            <a:r>
+              <a:rPr lang="en-US" sz="1800" b="1" dirty="0">
+                <a:solidFill>
+                  <a:schemeClr val="tx1"/>
+                </a:solidFill>
+              </a:rPr>
+              <a:t>Honest</a:t>
+            </a:r>
+            <a:endParaRPr lang="en-US" sz="1800" dirty="0"/>
+          </a:p>
+        </p:txBody>
+      </p:sp>
+      <p:sp>
+        <p:nvSpPr>
+          <p:cNvPr id="7" name="Trust text 1"/>
+          <p:cNvSpPr txBox="1"/>
+          <p:nvPr/>
+        </p:nvSpPr>
+        <p:spPr>
+          <a:xfrm>
+            <a:off x="4663440" y="1828800"/>
+            <a:ext cx="3931920" cy="685800"/>
+          </a:xfrm>
+          <a:prstGeom prst="rect">
+            <a:avLst/>
+          </a:prstGeom>
+          <a:noFill/>
+          <a:ln/>
+        </p:spPr>
+        <p:txBody>
+          <a:bodyPr wrap="square" lIns="0" tIns="0" rIns="0" bIns="0" rtlCol="0" anchor="t"/>
+          <a:lstStyle/>
+          <a:p>
+            <a:pPr indent="0" marL="0">
+              <a:buNone/>
+            </a:pPr>
+            <a:r>
+              <a:rPr lang="en-US" sz="1400" dirty="0">
+                <a:solidFill>
+                  <a:schemeClr val="accent3"/>
+                </a:solidFill>
+              </a:rPr>
+              <a:t>Unknown never counts as safe. Each place gets a confidence level, or a nudge to ask the kitchen.</a:t>
+            </a:r>
+            <a:endParaRPr lang="en-US" sz="1400" dirty="0"/>
+          </a:p>
+        </p:txBody>
+      </p:sp>
+      <p:sp>
+        <p:nvSpPr>
+          <p:cNvPr id="8" name="Trust circle 2"/>
+          <p:cNvSpPr/>
+          <p:nvPr/>
+        </p:nvSpPr>
+        <p:spPr>
+          <a:xfrm>
+            <a:off x="3931920" y="2651760"/>
+            <a:ext cx="548640" cy="548640"/>
+          </a:xfrm>
+          <a:prstGeom prst="ellipse">
+            <a:avLst/>
+          </a:prstGeom>
+          <a:solidFill>
+            <a:schemeClr val="accent1"/>
+          </a:solidFill>
+          <a:ln/>
+        </p:spPr>
+      </p:sp>
+      <p:pic>
+        <p:nvPicPr>
+          <p:cNvPr id="9" name="Trust icon 2" descr="Private icon">    </p:cNvPr>
+          <p:cNvPicPr>
+            <a:picLocks noChangeAspect="1"/>
+          </p:cNvPicPr>
+          <p:nvPr/>
+        </p:nvPicPr>
+        <p:blipFill>
+          <a:blip r:embed="rId3"/>
+          <a:stretch>
+            <a:fillRect/>
+          </a:stretch>
+        </p:blipFill>
+        <p:spPr>
+          <a:xfrm>
+            <a:off x="4069080" y="2788920"/>
+            <a:ext cx="274320" cy="274320"/>
+          </a:xfrm>
+          <a:prstGeom prst="rect">
+            <a:avLst/>
+          </a:prstGeom>
+        </p:spPr>
+      </p:pic>
+      <p:sp>
+        <p:nvSpPr>
+          <p:cNvPr id="10" name="Trust title 2"/>
+          <p:cNvSpPr txBox="1"/>
+          <p:nvPr/>
+        </p:nvSpPr>
+        <p:spPr>
+          <a:xfrm>
+            <a:off x="4663440" y="2606040"/>
+            <a:ext cx="3931920" cy="320040"/>
+          </a:xfrm>
+          <a:prstGeom prst="rect">
+            <a:avLst/>
+          </a:prstGeom>
+          <a:noFill/>
+          <a:ln/>
+        </p:spPr>
+        <p:txBody>
+          <a:bodyPr wrap="square" lIns="0" tIns="0" rIns="0" bIns="0" rtlCol="0" anchor="ctr"/>
+          <a:lstStyle/>
+          <a:p>
+            <a:pPr indent="0" marL="0">
+              <a:buNone/>
+            </a:pPr>
+            <a:r>
+              <a:rPr lang="en-US" sz="1800" b="1" dirty="0">
+                <a:solidFill>
+                  <a:schemeClr val="tx1"/>
+                </a:solidFill>
+              </a:rPr>
+              <a:t>Private</a:t>
+            </a:r>
+            <a:endParaRPr lang="en-US" sz="1800" dirty="0"/>
+          </a:p>
+        </p:txBody>
+      </p:sp>
+      <p:sp>
+        <p:nvSpPr>
+          <p:cNvPr id="11" name="Trust text 2"/>
+          <p:cNvSpPr txBox="1"/>
+          <p:nvPr/>
+        </p:nvSpPr>
+        <p:spPr>
+          <a:xfrm>
+            <a:off x="4663440" y="2926080"/>
+            <a:ext cx="3931920" cy="685800"/>
+          </a:xfrm>
+          <a:prstGeom prst="rect">
+            <a:avLst/>
+          </a:prstGeom>
+          <a:noFill/>
+          <a:ln/>
+        </p:spPr>
+        <p:txBody>
+          <a:bodyPr wrap="square" lIns="0" tIns="0" rIns="0" bIns="0" rtlCol="0" anchor="t"/>
+          <a:lstStyle/>
+          <a:p>
+            <a:pPr indent="0" marL="0">
+              <a:buNone/>
+            </a:pPr>
+            <a:r>
+              <a:rPr lang="en-US" sz="1400" dirty="0">
+                <a:solidFill>
+                  <a:schemeClr val="accent3"/>
+                </a:solidFill>
+              </a:rPr>
+              <a:t>We never store anyone's allergies. Your own Saint keeps them and shares them per request.</a:t>
+            </a:r>
+            <a:endParaRPr lang="en-US" sz="1400" dirty="0"/>
+          </a:p>
+        </p:txBody>
+      </p:sp>
+      <p:sp>
+        <p:nvSpPr>
+          <p:cNvPr id="12" name="Trust circle 3"/>
+          <p:cNvSpPr/>
+          <p:nvPr/>
+        </p:nvSpPr>
+        <p:spPr>
+          <a:xfrm>
+            <a:off x="3931920" y="3749040"/>
+            <a:ext cx="548640" cy="548640"/>
+          </a:xfrm>
+          <a:prstGeom prst="ellipse">
+            <a:avLst/>
+          </a:prstGeom>
+          <a:solidFill>
+            <a:schemeClr val="accent1"/>
+          </a:solidFill>
+          <a:ln/>
+        </p:spPr>
+      </p:sp>
+      <p:pic>
+        <p:nvPicPr>
+          <p:cNvPr id="13" name="Trust icon 3" descr="In your control icon">    </p:cNvPr>
+          <p:cNvPicPr>
+            <a:picLocks noChangeAspect="1"/>
+          </p:cNvPicPr>
+          <p:nvPr/>
+        </p:nvPicPr>
+        <p:blipFill>
+          <a:blip r:embed="rId4"/>
+          <a:stretch>
+            <a:fillRect/>
+          </a:stretch>
+        </p:blipFill>
+        <p:spPr>
+          <a:xfrm>
+            <a:off x="4069080" y="3886200"/>
+            <a:ext cx="274320" cy="274320"/>
+          </a:xfrm>
+          <a:prstGeom prst="rect">
+            <a:avLst/>
+          </a:prstGeom>
+        </p:spPr>
+      </p:pic>
+      <p:sp>
+        <p:nvSpPr>
+          <p:cNvPr id="14" name="Trust title 3"/>
+          <p:cNvSpPr txBox="1"/>
+          <p:nvPr/>
+        </p:nvSpPr>
+        <p:spPr>
+          <a:xfrm>
+            <a:off x="4663440" y="3703320"/>
+            <a:ext cx="3931920" cy="320040"/>
+          </a:xfrm>
+          <a:prstGeom prst="rect">
+            <a:avLst/>
+          </a:prstGeom>
+          <a:noFill/>
+          <a:ln/>
+        </p:spPr>
+        <p:txBody>
+          <a:bodyPr wrap="square" lIns="0" tIns="0" rIns="0" bIns="0" rtlCol="0" anchor="ctr"/>
+          <a:lstStyle/>
+          <a:p>
+            <a:pPr indent="0" marL="0">
+              <a:buNone/>
+            </a:pPr>
+            <a:r>
+              <a:rPr lang="en-US" sz="1800" b="1" dirty="0">
+                <a:solidFill>
+                  <a:schemeClr val="tx1"/>
+                </a:solidFill>
+              </a:rPr>
+              <a:t>In your control</a:t>
+            </a:r>
+            <a:endParaRPr lang="en-US" sz="1800" dirty="0"/>
+          </a:p>
+        </p:txBody>
+      </p:sp>
+      <p:sp>
+        <p:nvSpPr>
+          <p:cNvPr id="15" name="Trust text 3"/>
+          <p:cNvSpPr txBox="1"/>
+          <p:nvPr/>
+        </p:nvSpPr>
+        <p:spPr>
+          <a:xfrm>
+            <a:off x="4663440" y="4023360"/>
+            <a:ext cx="3931920" cy="685800"/>
+          </a:xfrm>
+          <a:prstGeom prst="rect">
+            <a:avLst/>
+          </a:prstGeom>
+          <a:noFill/>
+          <a:ln/>
+        </p:spPr>
+        <p:txBody>
+          <a:bodyPr wrap="square" lIns="0" tIns="0" rIns="0" bIns="0" rtlCol="0" anchor="t"/>
+          <a:lstStyle/>
+          <a:p>
+            <a:pPr indent="0" marL="0">
+              <a:buNone/>
+            </a:pPr>
+            <a:r>
+              <a:rPr lang="en-US" sz="1400" dirty="0">
+                <a:solidFill>
+                  <a:schemeClr val="accent3"/>
+                </a:solidFill>
+              </a:rPr>
+              <a:t>Saint asks before it sends a message, books a table or pays a deposit.</a:t>
+            </a:r>
+            <a:endParaRPr lang="en-US" sz="1400" dirty="0"/>
+          </a:p>
+        </p:txBody>
+      </p:sp>
+      <p:sp>
+        <p:nvSpPr>
+          <p:cNvPr id="25" name="Slide Number Placeholder 0"/>
+          <p:cNvSpPr>
+            <a:spLocks noGrp="1"/>
+          </p:cNvSpPr>
+          <p:nvPr>
+            <p:ph type="sldNum" sz="quarter" idx="4294967295"/>
+          </p:nvPr>
+        </p:nvSpPr>
+        <p:spPr>
+          <a:xfrm>
+            <a:off x="8321040" y="4754880"/>
+            <a:ext cx="457200" cy="228600"/>
+          </a:xfrm>
+          <a:prstGeom prst="rect">
+            <a:avLst/>
+          </a:prstGeom>
+          <a:extLst>
+            <a:ext uri="{C572A759-6A51-4108-AA02-DFA0A04FC94B}">
+              <ma14:wrappingTextBoxFlag xmlns:ma14="http://schemas.microsoft.com/office/mac/drawingml/2011/main" val="0"/>
+            </a:ext>
+          </a:extLst>
+        </p:spPr>
+        <p:txBody>
+          <a:bodyPr/>
+          <a:lstStyle>
+            <a:lvl1pPr>
+              <a:defRPr sz="1000">
+                <a:solidFill>
+                  <a:schemeClr val="accent3"/>
+                </a:solidFill>
+              </a:defRPr>
+            </a:lvl1pPr>
+          </a:lstStyle>
+          <a:p>
+            <a:pPr algn="r"/>
+            <a:fld id="{F7021451-1387-4CA6-816F-3879F97B5CBC}" type="slidenum">
+              <a:rPr b="0" lang="en-US"/>
+              <a:t>7</a:t>
+            </a:fld>
+            <a:endParaRPr lang="en-US"/>
+          </a:p>
+        </p:txBody>
+      </p:sp>
+    </p:spTree>
+  </p:cSld>
+  <p:clrMapOvr>
+    <a:masterClrMapping/>
+  </p:clrMapOvr>
+</p:sld>
+</file>
+
+<file path=ppt/slides/slide8.xml><?xml version="1.0" encoding="utf-8"?>
+<p:sld xmlns:a="http://schemas.openxmlformats.org/drawingml/2006/main" xmlns:r="http://schemas.openxmlformats.org/officeDocument/2006/relationships" xmlns:p="http://schemas.openxmlformats.org/presentationml/2006/main">
+  <p:cSld name="Slide 8">
     <p:spTree>
       <p:nvGrpSpPr>
         <p:cNvPr id="1" name=""/>

</xml_diff>